<commit_message>
Adding Pydantic. Also Load is the official term for taking data from the JSON and using the schema to create classes representing the data
</commit_message>
<xml_diff>
--- a/Project and Tool Layout.pptx
+++ b/Project and Tool Layout.pptx
@@ -3385,12 +3385,8 @@
               <a:t>📚 </a:t>
             </a:r>
             <a:r>
-              <a:rPr lang="en-US" sz="1100" b="1" u="sng" dirty="0" err="1"/>
-              <a:t>pg</a:t>
-            </a:r>
-            <a:r>
               <a:rPr lang="en-US" sz="1100" b="1" u="sng" dirty="0"/>
-              <a:t>-admin GUI</a:t>
+              <a:t>pg-admin GUI</a:t>
             </a:r>
             <a:endParaRPr lang="en-US" sz="1100" dirty="0"/>
           </a:p>
@@ -3866,7 +3862,7 @@
               <a:t>📚 </a:t>
             </a:r>
             <a:r>
-              <a:rPr lang="en-US" sz="1100" b="1" u="sng" dirty="0" err="1"/>
+              <a:rPr lang="en-US" sz="1100" b="1" u="sng" dirty="0"/>
               <a:t>SQLAlchemy</a:t>
             </a:r>
             <a:endParaRPr lang="en-US" sz="1200" b="1" u="sng" dirty="0"/>
@@ -3997,6 +3993,11 @@
               <a:rPr lang="en-US" dirty="0"/>
               <a:t>DB Schemas</a:t>
             </a:r>
+            <a:r>
+              <a:rPr lang="en-US" sz="1100" dirty="0"/>
+              <a:t>*</a:t>
+            </a:r>
+            <a:endParaRPr lang="en-US" dirty="0"/>
           </a:p>
           <a:p>
             <a:pPr algn="ctr"/>
@@ -4269,13 +4270,8 @@
             <a:pPr algn="ctr"/>
             <a:r>
               <a:rPr lang="en-US" sz="700" dirty="0"/>
-              <a:t>Console </a:t>
-            </a:r>
-            <a:r>
-              <a:rPr lang="en-US" sz="700" dirty="0" err="1"/>
-              <a:t>cmd</a:t>
-            </a:r>
-            <a:endParaRPr lang="en-US" sz="700" dirty="0"/>
+              <a:t>Console cmd</a:t>
+            </a:r>
           </a:p>
         </p:txBody>
       </p:sp>
@@ -4539,7 +4535,7 @@
             <a:pPr algn="ctr"/>
             <a:r>
               <a:rPr lang="en-US" sz="1600" dirty="0"/>
-              <a:t>Data Injector</a:t>
+              <a:t>Data Loader</a:t>
             </a:r>
           </a:p>
           <a:p>
@@ -4549,10 +4545,9 @@
               <a:t>📚 </a:t>
             </a:r>
             <a:r>
-              <a:rPr lang="en-US" sz="1050" b="1" u="sng" dirty="0" err="1"/>
+              <a:rPr lang="en-US" sz="1050" b="1" u="sng" dirty="0"/>
               <a:t>SQLAlchemy</a:t>
             </a:r>
-            <a:endParaRPr lang="en-US" sz="1050" b="1" u="sng" dirty="0"/>
           </a:p>
           <a:p>
             <a:pPr algn="ctr"/>
@@ -4717,7 +4712,7 @@
             </a:pPr>
             <a:r>
               <a:rPr lang="en-US" sz="1100" dirty="0"/>
-              <a:t>Inject data (DML)</a:t>
+              <a:t>Insert data (DML)</a:t>
             </a:r>
           </a:p>
           <a:p>
@@ -5593,6 +5588,65 @@
             <a:r>
               <a:rPr lang="en-US" sz="700" dirty="0"/>
               <a:t>data manip. language</a:t>
+            </a:r>
+          </a:p>
+        </p:txBody>
+      </p:sp>
+      <p:sp>
+        <p:nvSpPr>
+          <p:cNvPr id="154" name="Rectangle 153">
+            <a:extLst>
+              <a:ext uri="{FF2B5EF4-FFF2-40B4-BE49-F238E27FC236}">
+                <a16:creationId xmlns:a16="http://schemas.microsoft.com/office/drawing/2014/main" id="{476FAA6E-532E-811B-061E-21BC7C89326A}"/>
+              </a:ext>
+            </a:extLst>
+          </p:cNvPr>
+          <p:cNvSpPr/>
+          <p:nvPr/>
+        </p:nvSpPr>
+        <p:spPr>
+          <a:xfrm>
+            <a:off x="750159" y="6406284"/>
+            <a:ext cx="5345841" cy="249337"/>
+          </a:xfrm>
+          <a:prstGeom prst="rect">
+            <a:avLst/>
+          </a:prstGeom>
+          <a:solidFill>
+            <a:schemeClr val="accent5">
+              <a:lumMod val="20000"/>
+              <a:lumOff val="80000"/>
+            </a:schemeClr>
+          </a:solidFill>
+          <a:ln w="6350" cap="rnd"/>
+        </p:spPr>
+        <p:style>
+          <a:lnRef idx="2">
+            <a:schemeClr val="accent1">
+              <a:shade val="15000"/>
+            </a:schemeClr>
+          </a:lnRef>
+          <a:fillRef idx="1">
+            <a:schemeClr val="accent1"/>
+          </a:fillRef>
+          <a:effectRef idx="0">
+            <a:schemeClr val="accent1"/>
+          </a:effectRef>
+          <a:fontRef idx="minor">
+            <a:schemeClr val="lt1"/>
+          </a:fontRef>
+        </p:style>
+        <p:txBody>
+          <a:bodyPr lIns="91440" tIns="0" rIns="0" bIns="0" rtlCol="0" anchor="ctr"/>
+          <a:lstStyle/>
+          <a:p>
+            <a:r>
+              <a:rPr lang="en-US" sz="800" dirty="0">
+                <a:solidFill>
+                  <a:schemeClr val="tx1"/>
+                </a:solidFill>
+              </a:rPr>
+              <a:t>* Schemas in common parlance refers actually to the DB Models created for SQLAlchemy , but Pydantic uses it to refer to these Data Transfer Objects which define the interface boundary for the underlying DB Models</a:t>
             </a:r>
           </a:p>
         </p:txBody>

</xml_diff>

<commit_message>
Adding initial draft of Pydantic schemas, and minor other updates
</commit_message>
<xml_diff>
--- a/Project and Tool Layout.pptx
+++ b/Project and Tool Layout.pptx
@@ -4564,11 +4564,8 @@
             <a:pPr algn="ctr"/>
             <a:r>
               <a:rPr lang="en-US" sz="1100" dirty="0"/>
-              <a:t>= uses schemas to </a:t>
-            </a:r>
-          </a:p>
-          <a:p>
-            <a:pPr algn="ctr"/>
+              <a:t>= uses Pydantic schemas to </a:t>
+            </a:r>
             <a:r>
               <a:rPr lang="en-US" sz="1100" u="sng" dirty="0"/>
               <a:t>C</a:t>

</xml_diff>

<commit_message>
Preparing to set up Docker images with postgresql + pgvector + pg-admin
</commit_message>
<xml_diff>
--- a/Project and Tool Layout.pptx
+++ b/Project and Tool Layout.pptx
@@ -3335,7 +3335,7 @@
         </p:nvSpPr>
         <p:spPr>
           <a:xfrm>
-            <a:off x="6699799" y="1475054"/>
+            <a:off x="6707651" y="1475054"/>
             <a:ext cx="1196156" cy="4371762"/>
           </a:xfrm>
           <a:prstGeom prst="rect">
@@ -4737,7 +4737,7 @@
         </p:nvGrpSpPr>
         <p:grpSpPr>
           <a:xfrm>
-            <a:off x="6957480" y="2443683"/>
+            <a:off x="6965332" y="2443683"/>
             <a:ext cx="680794" cy="785917"/>
             <a:chOff x="8227377" y="3019807"/>
             <a:chExt cx="680794" cy="785917"/>
@@ -5360,7 +5360,7 @@
         </p:nvSpPr>
         <p:spPr>
           <a:xfrm>
-            <a:off x="6699800" y="1023326"/>
+            <a:off x="6707652" y="1023326"/>
             <a:ext cx="1196156" cy="321580"/>
           </a:xfrm>
           <a:prstGeom prst="rect">
@@ -5429,7 +5429,7 @@
         </p:nvSpPr>
         <p:spPr>
           <a:xfrm>
-            <a:off x="7023549" y="3324719"/>
+            <a:off x="7031401" y="3324719"/>
             <a:ext cx="548656" cy="208561"/>
           </a:xfrm>
           <a:prstGeom prst="rect">
@@ -5644,6 +5644,78 @@
                 </a:solidFill>
               </a:rPr>
               <a:t>* Schemas in common parlance refers actually to the DB Models created for SQLAlchemy , but Pydantic uses it to refer to these Data Transfer Objects which define the interface boundary for the underlying DB Models</a:t>
+            </a:r>
+          </a:p>
+        </p:txBody>
+      </p:sp>
+      <p:sp>
+        <p:nvSpPr>
+          <p:cNvPr id="156" name="TextBox 155">
+            <a:extLst>
+              <a:ext uri="{FF2B5EF4-FFF2-40B4-BE49-F238E27FC236}">
+                <a16:creationId xmlns:a16="http://schemas.microsoft.com/office/drawing/2014/main" id="{B2F6E475-DA7E-0118-0D9B-1058897002CF}"/>
+              </a:ext>
+            </a:extLst>
+          </p:cNvPr>
+          <p:cNvSpPr txBox="1"/>
+          <p:nvPr/>
+        </p:nvSpPr>
+        <p:spPr>
+          <a:xfrm>
+            <a:off x="5873611" y="2744030"/>
+            <a:ext cx="548227" cy="138499"/>
+          </a:xfrm>
+          <a:prstGeom prst="rect">
+            <a:avLst/>
+          </a:prstGeom>
+          <a:noFill/>
+        </p:spPr>
+        <p:txBody>
+          <a:bodyPr wrap="none" lIns="0" tIns="0" rIns="0" bIns="0" rtlCol="0">
+            <a:spAutoFit/>
+          </a:bodyPr>
+          <a:lstStyle/>
+          <a:p>
+            <a:pPr algn="ctr"/>
+            <a:r>
+              <a:rPr lang="en-US" sz="900" dirty="0"/>
+              <a:t>📚 asyncpg</a:t>
+            </a:r>
+          </a:p>
+        </p:txBody>
+      </p:sp>
+      <p:sp>
+        <p:nvSpPr>
+          <p:cNvPr id="157" name="TextBox 156">
+            <a:extLst>
+              <a:ext uri="{FF2B5EF4-FFF2-40B4-BE49-F238E27FC236}">
+                <a16:creationId xmlns:a16="http://schemas.microsoft.com/office/drawing/2014/main" id="{59052ABB-DB4C-5512-9E07-6F60D755833E}"/>
+              </a:ext>
+            </a:extLst>
+          </p:cNvPr>
+          <p:cNvSpPr txBox="1"/>
+          <p:nvPr/>
+        </p:nvSpPr>
+        <p:spPr>
+          <a:xfrm>
+            <a:off x="5873611" y="5175443"/>
+            <a:ext cx="548227" cy="138499"/>
+          </a:xfrm>
+          <a:prstGeom prst="rect">
+            <a:avLst/>
+          </a:prstGeom>
+          <a:noFill/>
+        </p:spPr>
+        <p:txBody>
+          <a:bodyPr wrap="none" lIns="0" tIns="0" rIns="0" bIns="0" rtlCol="0">
+            <a:spAutoFit/>
+          </a:bodyPr>
+          <a:lstStyle/>
+          <a:p>
+            <a:pPr algn="ctr"/>
+            <a:r>
+              <a:rPr lang="en-US" sz="900" dirty="0"/>
+              <a:t>📚 asyncpg</a:t>
             </a:r>
           </a:p>
         </p:txBody>

</xml_diff>

<commit_message>
Added docker compose yml and .env.example, both PostgreSQL and pg-admin are good to go
</commit_message>
<xml_diff>
--- a/Project and Tool Layout.pptx
+++ b/Project and Tool Layout.pptx
@@ -104,6 +104,11 @@
       </a:defRPr>
     </a:lvl9pPr>
   </p:defaultTextStyle>
+  <p:extLst>
+    <p:ext uri="{EFAFB233-063F-42B5-8137-9DF3F51BA10A}">
+      <p15:sldGuideLst xmlns:p15="http://schemas.microsoft.com/office/powerpoint/2012/main"/>
+    </p:ext>
+  </p:extLst>
 </p:presentation>
 </file>
 
@@ -254,7 +259,7 @@
           <a:p>
             <a:fld id="{E779FE8C-703A-4904-A4E0-13778480428C}" type="datetimeFigureOut">
               <a:rPr lang="en-US" smtClean="0"/>
-              <a:t>8/29/2026</a:t>
+              <a:t>8/30/2026</a:t>
             </a:fld>
             <a:endParaRPr lang="en-US"/>
           </a:p>
@@ -452,7 +457,7 @@
           <a:p>
             <a:fld id="{E779FE8C-703A-4904-A4E0-13778480428C}" type="datetimeFigureOut">
               <a:rPr lang="en-US" smtClean="0"/>
-              <a:t>8/29/2026</a:t>
+              <a:t>8/30/2026</a:t>
             </a:fld>
             <a:endParaRPr lang="en-US"/>
           </a:p>
@@ -660,7 +665,7 @@
           <a:p>
             <a:fld id="{E779FE8C-703A-4904-A4E0-13778480428C}" type="datetimeFigureOut">
               <a:rPr lang="en-US" smtClean="0"/>
-              <a:t>8/29/2026</a:t>
+              <a:t>8/30/2026</a:t>
             </a:fld>
             <a:endParaRPr lang="en-US"/>
           </a:p>
@@ -858,7 +863,7 @@
           <a:p>
             <a:fld id="{E779FE8C-703A-4904-A4E0-13778480428C}" type="datetimeFigureOut">
               <a:rPr lang="en-US" smtClean="0"/>
-              <a:t>8/29/2026</a:t>
+              <a:t>8/30/2026</a:t>
             </a:fld>
             <a:endParaRPr lang="en-US"/>
           </a:p>
@@ -1133,7 +1138,7 @@
           <a:p>
             <a:fld id="{E779FE8C-703A-4904-A4E0-13778480428C}" type="datetimeFigureOut">
               <a:rPr lang="en-US" smtClean="0"/>
-              <a:t>8/29/2026</a:t>
+              <a:t>8/30/2026</a:t>
             </a:fld>
             <a:endParaRPr lang="en-US"/>
           </a:p>
@@ -1398,7 +1403,7 @@
           <a:p>
             <a:fld id="{E779FE8C-703A-4904-A4E0-13778480428C}" type="datetimeFigureOut">
               <a:rPr lang="en-US" smtClean="0"/>
-              <a:t>8/29/2026</a:t>
+              <a:t>8/30/2026</a:t>
             </a:fld>
             <a:endParaRPr lang="en-US"/>
           </a:p>
@@ -1810,7 +1815,7 @@
           <a:p>
             <a:fld id="{E779FE8C-703A-4904-A4E0-13778480428C}" type="datetimeFigureOut">
               <a:rPr lang="en-US" smtClean="0"/>
-              <a:t>8/29/2026</a:t>
+              <a:t>8/30/2026</a:t>
             </a:fld>
             <a:endParaRPr lang="en-US"/>
           </a:p>
@@ -1951,7 +1956,7 @@
           <a:p>
             <a:fld id="{E779FE8C-703A-4904-A4E0-13778480428C}" type="datetimeFigureOut">
               <a:rPr lang="en-US" smtClean="0"/>
-              <a:t>8/29/2026</a:t>
+              <a:t>8/30/2026</a:t>
             </a:fld>
             <a:endParaRPr lang="en-US"/>
           </a:p>
@@ -2064,7 +2069,7 @@
           <a:p>
             <a:fld id="{E779FE8C-703A-4904-A4E0-13778480428C}" type="datetimeFigureOut">
               <a:rPr lang="en-US" smtClean="0"/>
-              <a:t>8/29/2026</a:t>
+              <a:t>8/30/2026</a:t>
             </a:fld>
             <a:endParaRPr lang="en-US"/>
           </a:p>
@@ -2375,7 +2380,7 @@
           <a:p>
             <a:fld id="{E779FE8C-703A-4904-A4E0-13778480428C}" type="datetimeFigureOut">
               <a:rPr lang="en-US" smtClean="0"/>
-              <a:t>8/29/2026</a:t>
+              <a:t>8/30/2026</a:t>
             </a:fld>
             <a:endParaRPr lang="en-US"/>
           </a:p>
@@ -2663,7 +2668,7 @@
           <a:p>
             <a:fld id="{E779FE8C-703A-4904-A4E0-13778480428C}" type="datetimeFigureOut">
               <a:rPr lang="en-US" smtClean="0"/>
-              <a:t>8/29/2026</a:t>
+              <a:t>8/30/2026</a:t>
             </a:fld>
             <a:endParaRPr lang="en-US"/>
           </a:p>
@@ -2904,7 +2909,7 @@
           <a:p>
             <a:fld id="{E779FE8C-703A-4904-A4E0-13778480428C}" type="datetimeFigureOut">
               <a:rPr lang="en-US" smtClean="0"/>
-              <a:t>8/29/2026</a:t>
+              <a:t>8/30/2026</a:t>
             </a:fld>
             <a:endParaRPr lang="en-US"/>
           </a:p>
@@ -3323,10 +3328,10 @@
       </p:grpSpPr>
       <p:sp>
         <p:nvSpPr>
-          <p:cNvPr id="97" name="Rectangle 96">
-            <a:extLst>
-              <a:ext uri="{FF2B5EF4-FFF2-40B4-BE49-F238E27FC236}">
-                <a16:creationId xmlns:a16="http://schemas.microsoft.com/office/drawing/2014/main" id="{3648F25D-F87B-BA73-4E34-C9B47F8DEFFF}"/>
+          <p:cNvPr id="15" name="Rectangle 14">
+            <a:extLst>
+              <a:ext uri="{FF2B5EF4-FFF2-40B4-BE49-F238E27FC236}">
+                <a16:creationId xmlns:a16="http://schemas.microsoft.com/office/drawing/2014/main" id="{9BCFF54A-ABDC-829F-D38E-19DC6F0A6EAE}"/>
               </a:ext>
             </a:extLst>
           </p:cNvPr>
@@ -3335,8 +3340,132 @@
         </p:nvSpPr>
         <p:spPr>
           <a:xfrm>
-            <a:off x="6707651" y="1475054"/>
-            <a:ext cx="1196156" cy="4371762"/>
+            <a:off x="6647580" y="1475052"/>
+            <a:ext cx="1314542" cy="4371762"/>
+          </a:xfrm>
+          <a:prstGeom prst="rect">
+            <a:avLst/>
+          </a:prstGeom>
+          <a:solidFill>
+            <a:schemeClr val="accent1">
+              <a:lumMod val="40000"/>
+              <a:lumOff val="60000"/>
+            </a:schemeClr>
+          </a:solidFill>
+        </p:spPr>
+        <p:style>
+          <a:lnRef idx="2">
+            <a:schemeClr val="accent1">
+              <a:shade val="15000"/>
+            </a:schemeClr>
+          </a:lnRef>
+          <a:fillRef idx="1">
+            <a:schemeClr val="accent1"/>
+          </a:fillRef>
+          <a:effectRef idx="0">
+            <a:schemeClr val="accent1"/>
+          </a:effectRef>
+          <a:fontRef idx="minor">
+            <a:schemeClr val="lt1"/>
+          </a:fontRef>
+        </p:style>
+        <p:txBody>
+          <a:bodyPr lIns="0" tIns="45720" rIns="0" bIns="0" rtlCol="0" anchor="t"/>
+          <a:lstStyle/>
+          <a:p>
+            <a:pPr algn="ctr"/>
+            <a:r>
+              <a:rPr lang="en-US" sz="900" b="1" dirty="0"/>
+              <a:t>🐳 Docker Container</a:t>
+            </a:r>
+          </a:p>
+          <a:p>
+            <a:pPr algn="ctr"/>
+            <a:r>
+              <a:rPr lang="en-US" sz="900" i="1" dirty="0"/>
+              <a:t>“pgvector/pgvector:pg17”</a:t>
+            </a:r>
+          </a:p>
+        </p:txBody>
+      </p:sp>
+      <p:sp>
+        <p:nvSpPr>
+          <p:cNvPr id="3" name="Rectangle 2">
+            <a:extLst>
+              <a:ext uri="{FF2B5EF4-FFF2-40B4-BE49-F238E27FC236}">
+                <a16:creationId xmlns:a16="http://schemas.microsoft.com/office/drawing/2014/main" id="{CAAC8FDD-2CDB-1421-3C89-7271865A8AA6}"/>
+              </a:ext>
+            </a:extLst>
+          </p:cNvPr>
+          <p:cNvSpPr/>
+          <p:nvPr/>
+        </p:nvSpPr>
+        <p:spPr>
+          <a:xfrm>
+            <a:off x="6647580" y="300845"/>
+            <a:ext cx="1314542" cy="922951"/>
+          </a:xfrm>
+          <a:prstGeom prst="rect">
+            <a:avLst/>
+          </a:prstGeom>
+          <a:solidFill>
+            <a:schemeClr val="accent1">
+              <a:lumMod val="40000"/>
+              <a:lumOff val="60000"/>
+            </a:schemeClr>
+          </a:solidFill>
+        </p:spPr>
+        <p:style>
+          <a:lnRef idx="2">
+            <a:schemeClr val="accent1">
+              <a:shade val="15000"/>
+            </a:schemeClr>
+          </a:lnRef>
+          <a:fillRef idx="1">
+            <a:schemeClr val="accent1"/>
+          </a:fillRef>
+          <a:effectRef idx="0">
+            <a:schemeClr val="accent1"/>
+          </a:effectRef>
+          <a:fontRef idx="minor">
+            <a:schemeClr val="lt1"/>
+          </a:fontRef>
+        </p:style>
+        <p:txBody>
+          <a:bodyPr lIns="0" tIns="45720" rIns="0" bIns="0" rtlCol="0" anchor="t"/>
+          <a:lstStyle/>
+          <a:p>
+            <a:pPr algn="ctr"/>
+            <a:r>
+              <a:rPr lang="en-US" sz="900" b="1" dirty="0"/>
+              <a:t>🐳 Docker Container</a:t>
+            </a:r>
+          </a:p>
+          <a:p>
+            <a:pPr algn="ctr"/>
+            <a:r>
+              <a:rPr lang="en-US" sz="900" i="1" dirty="0"/>
+              <a:t>“dpage/pgadmin4”</a:t>
+            </a:r>
+          </a:p>
+        </p:txBody>
+      </p:sp>
+      <p:sp>
+        <p:nvSpPr>
+          <p:cNvPr id="97" name="Rectangle 96">
+            <a:extLst>
+              <a:ext uri="{FF2B5EF4-FFF2-40B4-BE49-F238E27FC236}">
+                <a16:creationId xmlns:a16="http://schemas.microsoft.com/office/drawing/2014/main" id="{3648F25D-F87B-BA73-4E34-C9B47F8DEFFF}"/>
+              </a:ext>
+            </a:extLst>
+          </p:cNvPr>
+          <p:cNvSpPr/>
+          <p:nvPr/>
+        </p:nvSpPr>
+        <p:spPr>
+          <a:xfrm>
+            <a:off x="6706773" y="2054076"/>
+            <a:ext cx="1196156" cy="3392277"/>
           </a:xfrm>
           <a:prstGeom prst="rect">
             <a:avLst/>
@@ -3369,26 +3498,10 @@
           <a:lstStyle/>
           <a:p>
             <a:pPr algn="ctr"/>
-            <a:endParaRPr lang="en-US" sz="600" dirty="0"/>
-          </a:p>
-          <a:p>
-            <a:pPr algn="ctr"/>
             <a:r>
               <a:rPr lang="en-US" sz="1600" dirty="0"/>
               <a:t>PostgreSQL Server</a:t>
             </a:r>
-          </a:p>
-          <a:p>
-            <a:pPr algn="ctr"/>
-            <a:r>
-              <a:rPr lang="en-US" sz="1100" dirty="0"/>
-              <a:t>📚 </a:t>
-            </a:r>
-            <a:r>
-              <a:rPr lang="en-US" sz="1100" b="1" u="sng" dirty="0"/>
-              <a:t>pg-admin GUI</a:t>
-            </a:r>
-            <a:endParaRPr lang="en-US" sz="1100" dirty="0"/>
           </a:p>
         </p:txBody>
       </p:sp>
@@ -4737,7 +4850,7 @@
         </p:nvGrpSpPr>
         <p:grpSpPr>
           <a:xfrm>
-            <a:off x="6965332" y="2443683"/>
+            <a:off x="6970528" y="2629312"/>
             <a:ext cx="680794" cy="785917"/>
             <a:chOff x="8227377" y="3019807"/>
             <a:chExt cx="680794" cy="785917"/>
@@ -4915,7 +5028,7 @@
         <p:spPr>
           <a:xfrm>
             <a:off x="5646269" y="2716483"/>
-            <a:ext cx="1053530" cy="0"/>
+            <a:ext cx="1060504" cy="0"/>
           </a:xfrm>
           <a:prstGeom prst="straightConnector1">
             <a:avLst/>
@@ -4960,7 +5073,7 @@
         <p:spPr>
           <a:xfrm>
             <a:off x="5646269" y="5147897"/>
-            <a:ext cx="1053530" cy="0"/>
+            <a:ext cx="1060504" cy="0"/>
           </a:xfrm>
           <a:prstGeom prst="straightConnector1">
             <a:avLst/>
@@ -5360,7 +5473,7 @@
         </p:nvSpPr>
         <p:spPr>
           <a:xfrm>
-            <a:off x="6707652" y="1023326"/>
+            <a:off x="6706773" y="5909454"/>
             <a:ext cx="1196156" cy="321580"/>
           </a:xfrm>
           <a:prstGeom prst="rect">
@@ -5417,10 +5530,10 @@
       </p:sp>
       <p:sp>
         <p:nvSpPr>
-          <p:cNvPr id="149" name="Rectangle 148">
-            <a:extLst>
-              <a:ext uri="{FF2B5EF4-FFF2-40B4-BE49-F238E27FC236}">
-                <a16:creationId xmlns:a16="http://schemas.microsoft.com/office/drawing/2014/main" id="{82C30CE7-750F-EA4E-A684-D28105A3966B}"/>
+          <p:cNvPr id="151" name="Rectangle 150">
+            <a:extLst>
+              <a:ext uri="{FF2B5EF4-FFF2-40B4-BE49-F238E27FC236}">
+                <a16:creationId xmlns:a16="http://schemas.microsoft.com/office/drawing/2014/main" id="{A1F35192-1F23-1A7E-F982-7D8C8411CE14}"/>
               </a:ext>
             </a:extLst>
           </p:cNvPr>
@@ -5429,17 +5542,16 @@
         </p:nvSpPr>
         <p:spPr>
           <a:xfrm>
-            <a:off x="7031401" y="3324719"/>
-            <a:ext cx="548656" cy="208561"/>
+            <a:off x="4581610" y="3022272"/>
+            <a:ext cx="873082" cy="248173"/>
           </a:xfrm>
           <a:prstGeom prst="rect">
             <a:avLst/>
           </a:prstGeom>
           <a:solidFill>
-            <a:schemeClr val="accent2">
-              <a:lumMod val="75000"/>
-            </a:schemeClr>
+            <a:srgbClr val="B0B0B0"/>
           </a:solidFill>
+          <a:ln w="6350" cap="rnd"/>
         </p:spPr>
         <p:style>
           <a:lnRef idx="2">
@@ -5458,23 +5570,30 @@
           </a:fontRef>
         </p:style>
         <p:txBody>
-          <a:bodyPr rtlCol="0" anchor="ctr"/>
+          <a:bodyPr lIns="0" tIns="0" rIns="0" bIns="0" rtlCol="0" anchor="ctr"/>
           <a:lstStyle/>
           <a:p>
             <a:pPr algn="ctr"/>
             <a:r>
-              <a:rPr lang="en-US" sz="1050" dirty="0"/>
-              <a:t>admin</a:t>
-            </a:r>
-          </a:p>
-        </p:txBody>
-      </p:sp>
-      <p:sp>
-        <p:nvSpPr>
-          <p:cNvPr id="151" name="Rectangle 150">
-            <a:extLst>
-              <a:ext uri="{FF2B5EF4-FFF2-40B4-BE49-F238E27FC236}">
-                <a16:creationId xmlns:a16="http://schemas.microsoft.com/office/drawing/2014/main" id="{A1F35192-1F23-1A7E-F982-7D8C8411CE14}"/>
+              <a:rPr lang="en-US" sz="700" dirty="0"/>
+              <a:t>DDL = </a:t>
+            </a:r>
+          </a:p>
+          <a:p>
+            <a:pPr algn="ctr"/>
+            <a:r>
+              <a:rPr lang="en-US" sz="700" dirty="0"/>
+              <a:t>data def. language</a:t>
+            </a:r>
+          </a:p>
+        </p:txBody>
+      </p:sp>
+      <p:sp>
+        <p:nvSpPr>
+          <p:cNvPr id="152" name="Rectangle 151">
+            <a:extLst>
+              <a:ext uri="{FF2B5EF4-FFF2-40B4-BE49-F238E27FC236}">
+                <a16:creationId xmlns:a16="http://schemas.microsoft.com/office/drawing/2014/main" id="{1FCB8362-7307-7200-10E2-DA71601A0359}"/>
               </a:ext>
             </a:extLst>
           </p:cNvPr>
@@ -5483,8 +5602,8 @@
         </p:nvSpPr>
         <p:spPr>
           <a:xfrm>
-            <a:off x="4581610" y="3022272"/>
-            <a:ext cx="873082" cy="248173"/>
+            <a:off x="4581609" y="5900631"/>
+            <a:ext cx="873083" cy="249337"/>
           </a:xfrm>
           <a:prstGeom prst="rect">
             <a:avLst/>
@@ -5517,24 +5636,24 @@
             <a:pPr algn="ctr"/>
             <a:r>
               <a:rPr lang="en-US" sz="700" dirty="0"/>
-              <a:t>DDL = </a:t>
+              <a:t>DML = </a:t>
             </a:r>
           </a:p>
           <a:p>
             <a:pPr algn="ctr"/>
             <a:r>
               <a:rPr lang="en-US" sz="700" dirty="0"/>
-              <a:t>data def. language</a:t>
-            </a:r>
-          </a:p>
-        </p:txBody>
-      </p:sp>
-      <p:sp>
-        <p:nvSpPr>
-          <p:cNvPr id="152" name="Rectangle 151">
-            <a:extLst>
-              <a:ext uri="{FF2B5EF4-FFF2-40B4-BE49-F238E27FC236}">
-                <a16:creationId xmlns:a16="http://schemas.microsoft.com/office/drawing/2014/main" id="{1FCB8362-7307-7200-10E2-DA71601A0359}"/>
+              <a:t>data manip. language</a:t>
+            </a:r>
+          </a:p>
+        </p:txBody>
+      </p:sp>
+      <p:sp>
+        <p:nvSpPr>
+          <p:cNvPr id="154" name="Rectangle 153">
+            <a:extLst>
+              <a:ext uri="{FF2B5EF4-FFF2-40B4-BE49-F238E27FC236}">
+                <a16:creationId xmlns:a16="http://schemas.microsoft.com/office/drawing/2014/main" id="{476FAA6E-532E-811B-061E-21BC7C89326A}"/>
               </a:ext>
             </a:extLst>
           </p:cNvPr>
@@ -5543,14 +5662,14 @@
         </p:nvSpPr>
         <p:spPr>
           <a:xfrm>
-            <a:off x="4581609" y="5900631"/>
-            <a:ext cx="873083" cy="249337"/>
+            <a:off x="750159" y="6406284"/>
+            <a:ext cx="5345841" cy="249337"/>
           </a:xfrm>
           <a:prstGeom prst="rect">
             <a:avLst/>
           </a:prstGeom>
           <a:solidFill>
-            <a:srgbClr val="B0B0B0"/>
+            <a:schemeClr val="bg1"/>
           </a:solidFill>
           <a:ln w="6350" cap="rnd"/>
         </p:spPr>
@@ -5571,30 +5690,98 @@
           </a:fontRef>
         </p:style>
         <p:txBody>
-          <a:bodyPr lIns="0" tIns="0" rIns="0" bIns="0" rtlCol="0" anchor="ctr"/>
+          <a:bodyPr lIns="91440" tIns="0" rIns="0" bIns="0" rtlCol="0" anchor="ctr"/>
+          <a:lstStyle/>
+          <a:p>
+            <a:r>
+              <a:rPr lang="en-US" sz="800" dirty="0">
+                <a:solidFill>
+                  <a:schemeClr val="tx1"/>
+                </a:solidFill>
+              </a:rPr>
+              <a:t>* Schemas in common parlance refers actually to the DB Models created for SQLAlchemy , but Pydantic uses it to refer to these Data Transfer Objects which define the interface boundary for the underlying DB Models</a:t>
+            </a:r>
+          </a:p>
+        </p:txBody>
+      </p:sp>
+      <p:sp>
+        <p:nvSpPr>
+          <p:cNvPr id="156" name="TextBox 155">
+            <a:extLst>
+              <a:ext uri="{FF2B5EF4-FFF2-40B4-BE49-F238E27FC236}">
+                <a16:creationId xmlns:a16="http://schemas.microsoft.com/office/drawing/2014/main" id="{B2F6E475-DA7E-0118-0D9B-1058897002CF}"/>
+              </a:ext>
+            </a:extLst>
+          </p:cNvPr>
+          <p:cNvSpPr txBox="1"/>
+          <p:nvPr/>
+        </p:nvSpPr>
+        <p:spPr>
+          <a:xfrm>
+            <a:off x="5873611" y="2744030"/>
+            <a:ext cx="548227" cy="138499"/>
+          </a:xfrm>
+          <a:prstGeom prst="rect">
+            <a:avLst/>
+          </a:prstGeom>
+          <a:noFill/>
+        </p:spPr>
+        <p:txBody>
+          <a:bodyPr wrap="none" lIns="0" tIns="0" rIns="0" bIns="0" rtlCol="0">
+            <a:spAutoFit/>
+          </a:bodyPr>
           <a:lstStyle/>
           <a:p>
             <a:pPr algn="ctr"/>
             <a:r>
-              <a:rPr lang="en-US" sz="700" dirty="0"/>
-              <a:t>DML = </a:t>
-            </a:r>
-          </a:p>
+              <a:rPr lang="en-US" sz="900" dirty="0"/>
+              <a:t>📚 asyncpg</a:t>
+            </a:r>
+          </a:p>
+        </p:txBody>
+      </p:sp>
+      <p:sp>
+        <p:nvSpPr>
+          <p:cNvPr id="157" name="TextBox 156">
+            <a:extLst>
+              <a:ext uri="{FF2B5EF4-FFF2-40B4-BE49-F238E27FC236}">
+                <a16:creationId xmlns:a16="http://schemas.microsoft.com/office/drawing/2014/main" id="{59052ABB-DB4C-5512-9E07-6F60D755833E}"/>
+              </a:ext>
+            </a:extLst>
+          </p:cNvPr>
+          <p:cNvSpPr txBox="1"/>
+          <p:nvPr/>
+        </p:nvSpPr>
+        <p:spPr>
+          <a:xfrm>
+            <a:off x="5873611" y="5175443"/>
+            <a:ext cx="548227" cy="138499"/>
+          </a:xfrm>
+          <a:prstGeom prst="rect">
+            <a:avLst/>
+          </a:prstGeom>
+          <a:noFill/>
+        </p:spPr>
+        <p:txBody>
+          <a:bodyPr wrap="none" lIns="0" tIns="0" rIns="0" bIns="0" rtlCol="0">
+            <a:spAutoFit/>
+          </a:bodyPr>
+          <a:lstStyle/>
           <a:p>
             <a:pPr algn="ctr"/>
             <a:r>
-              <a:rPr lang="en-US" sz="700" dirty="0"/>
-              <a:t>data manip. language</a:t>
-            </a:r>
-          </a:p>
-        </p:txBody>
-      </p:sp>
-      <p:sp>
-        <p:nvSpPr>
-          <p:cNvPr id="154" name="Rectangle 153">
-            <a:extLst>
-              <a:ext uri="{FF2B5EF4-FFF2-40B4-BE49-F238E27FC236}">
-                <a16:creationId xmlns:a16="http://schemas.microsoft.com/office/drawing/2014/main" id="{476FAA6E-532E-811B-061E-21BC7C89326A}"/>
+              <a:rPr lang="en-US" sz="900" dirty="0"/>
+              <a:t>📚 asyncpg</a:t>
+            </a:r>
+          </a:p>
+        </p:txBody>
+      </p:sp>
+      <p:sp>
+        <p:nvSpPr>
+          <p:cNvPr id="158" name="Rectangle 157">
+            <a:extLst>
+              <a:ext uri="{FF2B5EF4-FFF2-40B4-BE49-F238E27FC236}">
+                <a16:creationId xmlns:a16="http://schemas.microsoft.com/office/drawing/2014/main" id="{B0430F05-8A2C-8D80-2161-C4CC2231EF01}"/>
               </a:ext>
             </a:extLst>
           </p:cNvPr>
@@ -5603,19 +5790,18 @@
         </p:nvSpPr>
         <p:spPr>
           <a:xfrm>
-            <a:off x="750159" y="6406284"/>
-            <a:ext cx="5345841" cy="249337"/>
+            <a:off x="6707651" y="681289"/>
+            <a:ext cx="1196156" cy="500584"/>
           </a:xfrm>
           <a:prstGeom prst="rect">
             <a:avLst/>
           </a:prstGeom>
           <a:solidFill>
-            <a:schemeClr val="accent5">
-              <a:lumMod val="20000"/>
-              <a:lumOff val="80000"/>
+            <a:schemeClr val="accent2">
+              <a:lumMod val="60000"/>
+              <a:lumOff val="40000"/>
             </a:schemeClr>
           </a:solidFill>
-          <a:ln w="6350" cap="rnd"/>
         </p:spPr>
         <p:style>
           <a:lnRef idx="2">
@@ -5634,88 +5820,135 @@
           </a:fontRef>
         </p:style>
         <p:txBody>
-          <a:bodyPr lIns="91440" tIns="0" rIns="0" bIns="0" rtlCol="0" anchor="ctr"/>
-          <a:lstStyle/>
-          <a:p>
-            <a:r>
-              <a:rPr lang="en-US" sz="800" dirty="0">
-                <a:solidFill>
-                  <a:schemeClr val="tx1"/>
-                </a:solidFill>
-              </a:rPr>
-              <a:t>* Schemas in common parlance refers actually to the DB Models created for SQLAlchemy , but Pydantic uses it to refer to these Data Transfer Objects which define the interface boundary for the underlying DB Models</a:t>
-            </a:r>
-          </a:p>
-        </p:txBody>
-      </p:sp>
-      <p:sp>
-        <p:nvSpPr>
-          <p:cNvPr id="156" name="TextBox 155">
-            <a:extLst>
-              <a:ext uri="{FF2B5EF4-FFF2-40B4-BE49-F238E27FC236}">
-                <a16:creationId xmlns:a16="http://schemas.microsoft.com/office/drawing/2014/main" id="{B2F6E475-DA7E-0118-0D9B-1058897002CF}"/>
-              </a:ext>
-            </a:extLst>
-          </p:cNvPr>
-          <p:cNvSpPr txBox="1"/>
+          <a:bodyPr lIns="0" tIns="0" rIns="0" bIns="0" rtlCol="0" anchor="t"/>
+          <a:lstStyle/>
+          <a:p>
+            <a:pPr algn="ctr"/>
+            <a:endParaRPr lang="en-US" sz="600" dirty="0"/>
+          </a:p>
+          <a:p>
+            <a:pPr algn="ctr"/>
+            <a:r>
+              <a:rPr lang="en-US" sz="1200" dirty="0"/>
+              <a:t>DB Web Viewer</a:t>
+            </a:r>
+          </a:p>
+          <a:p>
+            <a:pPr algn="ctr"/>
+            <a:r>
+              <a:rPr lang="en-US" sz="1100" dirty="0"/>
+              <a:t>📚 </a:t>
+            </a:r>
+            <a:r>
+              <a:rPr lang="en-US" sz="1100" b="1" u="sng" dirty="0"/>
+              <a:t>pg-admin</a:t>
+            </a:r>
+            <a:endParaRPr lang="en-US" sz="1100" dirty="0"/>
+          </a:p>
+        </p:txBody>
+      </p:sp>
+      <p:cxnSp>
+        <p:nvCxnSpPr>
+          <p:cNvPr id="159" name="Straight Arrow Connector 158">
+            <a:extLst>
+              <a:ext uri="{FF2B5EF4-FFF2-40B4-BE49-F238E27FC236}">
+                <a16:creationId xmlns:a16="http://schemas.microsoft.com/office/drawing/2014/main" id="{A1CFC8EC-97A6-89F7-7896-FC2523FC381B}"/>
+              </a:ext>
+            </a:extLst>
+          </p:cNvPr>
+          <p:cNvCxnSpPr>
+            <a:cxnSpLocks/>
+            <a:stCxn id="3" idx="2"/>
+            <a:endCxn id="15" idx="0"/>
+          </p:cNvCxnSpPr>
           <p:nvPr/>
-        </p:nvSpPr>
+        </p:nvCxnSpPr>
         <p:spPr>
           <a:xfrm>
-            <a:off x="5873611" y="2744030"/>
-            <a:ext cx="548227" cy="138499"/>
+            <a:off x="7304851" y="1223796"/>
+            <a:ext cx="0" cy="251256"/>
+          </a:xfrm>
+          <a:prstGeom prst="straightConnector1">
+            <a:avLst/>
+          </a:prstGeom>
+          <a:ln w="12700">
+            <a:solidFill>
+              <a:schemeClr val="tx1"/>
+            </a:solidFill>
+            <a:headEnd type="arrow"/>
+            <a:tailEnd type="arrow"/>
+          </a:ln>
+        </p:spPr>
+        <p:style>
+          <a:lnRef idx="1">
+            <a:schemeClr val="accent1"/>
+          </a:lnRef>
+          <a:fillRef idx="0">
+            <a:schemeClr val="accent1"/>
+          </a:fillRef>
+          <a:effectRef idx="0">
+            <a:schemeClr val="accent1"/>
+          </a:effectRef>
+          <a:fontRef idx="minor">
+            <a:schemeClr val="tx1"/>
+          </a:fontRef>
+        </p:style>
+      </p:cxnSp>
+      <p:sp>
+        <p:nvSpPr>
+          <p:cNvPr id="27" name="Rectangle 26">
+            <a:extLst>
+              <a:ext uri="{FF2B5EF4-FFF2-40B4-BE49-F238E27FC236}">
+                <a16:creationId xmlns:a16="http://schemas.microsoft.com/office/drawing/2014/main" id="{91F4102F-EE91-ED5F-D7CB-CA4F588BB5A7}"/>
+              </a:ext>
+            </a:extLst>
+          </p:cNvPr>
+          <p:cNvSpPr/>
+          <p:nvPr/>
+        </p:nvSpPr>
+        <p:spPr>
+          <a:xfrm>
+            <a:off x="6839157" y="3613093"/>
+            <a:ext cx="931388" cy="347071"/>
           </a:xfrm>
           <a:prstGeom prst="rect">
             <a:avLst/>
           </a:prstGeom>
-          <a:noFill/>
-        </p:spPr>
-        <p:txBody>
-          <a:bodyPr wrap="none" lIns="0" tIns="0" rIns="0" bIns="0" rtlCol="0">
-            <a:spAutoFit/>
-          </a:bodyPr>
+          <a:solidFill>
+            <a:schemeClr val="accent2">
+              <a:lumMod val="60000"/>
+              <a:lumOff val="40000"/>
+            </a:schemeClr>
+          </a:solidFill>
+        </p:spPr>
+        <p:style>
+          <a:lnRef idx="2">
+            <a:schemeClr val="accent1">
+              <a:shade val="15000"/>
+            </a:schemeClr>
+          </a:lnRef>
+          <a:fillRef idx="1">
+            <a:schemeClr val="accent1"/>
+          </a:fillRef>
+          <a:effectRef idx="0">
+            <a:schemeClr val="accent1"/>
+          </a:effectRef>
+          <a:fontRef idx="minor">
+            <a:schemeClr val="lt1"/>
+          </a:fontRef>
+        </p:style>
+        <p:txBody>
+          <a:bodyPr lIns="0" tIns="0" rIns="0" bIns="0" rtlCol="0" anchor="ctr"/>
           <a:lstStyle/>
           <a:p>
             <a:pPr algn="ctr"/>
             <a:r>
-              <a:rPr lang="en-US" sz="900" dirty="0"/>
-              <a:t>📚 asyncpg</a:t>
-            </a:r>
-          </a:p>
-        </p:txBody>
-      </p:sp>
-      <p:sp>
-        <p:nvSpPr>
-          <p:cNvPr id="157" name="TextBox 156">
-            <a:extLst>
-              <a:ext uri="{FF2B5EF4-FFF2-40B4-BE49-F238E27FC236}">
-                <a16:creationId xmlns:a16="http://schemas.microsoft.com/office/drawing/2014/main" id="{59052ABB-DB4C-5512-9E07-6F60D755833E}"/>
-              </a:ext>
-            </a:extLst>
-          </p:cNvPr>
-          <p:cNvSpPr txBox="1"/>
-          <p:nvPr/>
-        </p:nvSpPr>
-        <p:spPr>
-          <a:xfrm>
-            <a:off x="5873611" y="5175443"/>
-            <a:ext cx="548227" cy="138499"/>
-          </a:xfrm>
-          <a:prstGeom prst="rect">
-            <a:avLst/>
-          </a:prstGeom>
-          <a:noFill/>
-        </p:spPr>
-        <p:txBody>
-          <a:bodyPr wrap="none" lIns="0" tIns="0" rIns="0" bIns="0" rtlCol="0">
-            <a:spAutoFit/>
-          </a:bodyPr>
-          <a:lstStyle/>
-          <a:p>
-            <a:pPr algn="ctr"/>
-            <a:r>
-              <a:rPr lang="en-US" sz="900" dirty="0"/>
-              <a:t>📚 asyncpg</a:t>
+              <a:rPr lang="en-US" sz="1200" dirty="0"/>
+              <a:t>📚 </a:t>
+            </a:r>
+            <a:r>
+              <a:rPr lang="en-US" sz="1200" b="1" u="sng" dirty="0"/>
+              <a:t>pg-vector</a:t>
             </a:r>
           </a:p>
         </p:txBody>

</xml_diff>

<commit_message>
Added ability to grab the DB url and create a session from it
</commit_message>
<xml_diff>
--- a/Project and Tool Layout.pptx
+++ b/Project and Tool Layout.pptx
@@ -5257,7 +5257,7 @@
             <a:pPr algn="ctr"/>
             <a:r>
               <a:rPr lang="en-US" sz="1400" b="1" dirty="0"/>
-              <a:t>4</a:t>
+              <a:t>5</a:t>
             </a:r>
           </a:p>
         </p:txBody>
@@ -5311,7 +5311,7 @@
             <a:pPr algn="ctr"/>
             <a:r>
               <a:rPr lang="en-US" sz="1400" b="1" dirty="0"/>
-              <a:t>5</a:t>
+              <a:t>6</a:t>
             </a:r>
           </a:p>
         </p:txBody>
@@ -5365,7 +5365,7 @@
             <a:pPr algn="ctr"/>
             <a:r>
               <a:rPr lang="en-US" sz="1400" b="1" dirty="0"/>
-              <a:t>6</a:t>
+              <a:t>7</a:t>
             </a:r>
           </a:p>
         </p:txBody>
@@ -5949,6 +5949,114 @@
             <a:r>
               <a:rPr lang="en-US" sz="1200" b="1" u="sng" dirty="0"/>
               <a:t>pg-vector</a:t>
+            </a:r>
+          </a:p>
+        </p:txBody>
+      </p:sp>
+      <p:sp>
+        <p:nvSpPr>
+          <p:cNvPr id="37" name="Flowchart: Off-page Connector 36">
+            <a:extLst>
+              <a:ext uri="{FF2B5EF4-FFF2-40B4-BE49-F238E27FC236}">
+                <a16:creationId xmlns:a16="http://schemas.microsoft.com/office/drawing/2014/main" id="{A1051958-E2DE-29E1-E221-338CBEA4536B}"/>
+              </a:ext>
+            </a:extLst>
+          </p:cNvPr>
+          <p:cNvSpPr/>
+          <p:nvPr/>
+        </p:nvSpPr>
+        <p:spPr>
+          <a:xfrm rot="16200000">
+            <a:off x="6405930" y="180705"/>
+            <a:ext cx="186884" cy="240280"/>
+          </a:xfrm>
+          <a:prstGeom prst="flowChartOffpageConnector">
+            <a:avLst/>
+          </a:prstGeom>
+          <a:solidFill>
+            <a:schemeClr val="accent6">
+              <a:lumMod val="75000"/>
+            </a:schemeClr>
+          </a:solidFill>
+        </p:spPr>
+        <p:style>
+          <a:lnRef idx="2">
+            <a:schemeClr val="accent1">
+              <a:shade val="15000"/>
+            </a:schemeClr>
+          </a:lnRef>
+          <a:fillRef idx="1">
+            <a:schemeClr val="accent1"/>
+          </a:fillRef>
+          <a:effectRef idx="0">
+            <a:schemeClr val="accent1"/>
+          </a:effectRef>
+          <a:fontRef idx="minor">
+            <a:schemeClr val="lt1"/>
+          </a:fontRef>
+        </p:style>
+        <p:txBody>
+          <a:bodyPr vert="vert" rtlCol="0" anchor="ctr"/>
+          <a:lstStyle/>
+          <a:p>
+            <a:pPr algn="ctr"/>
+            <a:r>
+              <a:rPr lang="en-US" sz="1400" b="1" dirty="0"/>
+              <a:t>4</a:t>
+            </a:r>
+          </a:p>
+        </p:txBody>
+      </p:sp>
+      <p:sp>
+        <p:nvSpPr>
+          <p:cNvPr id="38" name="Flowchart: Off-page Connector 37">
+            <a:extLst>
+              <a:ext uri="{FF2B5EF4-FFF2-40B4-BE49-F238E27FC236}">
+                <a16:creationId xmlns:a16="http://schemas.microsoft.com/office/drawing/2014/main" id="{82D3151C-F370-4949-4E46-2EFDE6393040}"/>
+              </a:ext>
+            </a:extLst>
+          </p:cNvPr>
+          <p:cNvSpPr/>
+          <p:nvPr/>
+        </p:nvSpPr>
+        <p:spPr>
+          <a:xfrm rot="16200000">
+            <a:off x="6405930" y="1354912"/>
+            <a:ext cx="186884" cy="240280"/>
+          </a:xfrm>
+          <a:prstGeom prst="flowChartOffpageConnector">
+            <a:avLst/>
+          </a:prstGeom>
+          <a:solidFill>
+            <a:schemeClr val="accent6">
+              <a:lumMod val="75000"/>
+            </a:schemeClr>
+          </a:solidFill>
+        </p:spPr>
+        <p:style>
+          <a:lnRef idx="2">
+            <a:schemeClr val="accent1">
+              <a:shade val="15000"/>
+            </a:schemeClr>
+          </a:lnRef>
+          <a:fillRef idx="1">
+            <a:schemeClr val="accent1"/>
+          </a:fillRef>
+          <a:effectRef idx="0">
+            <a:schemeClr val="accent1"/>
+          </a:effectRef>
+          <a:fontRef idx="minor">
+            <a:schemeClr val="lt1"/>
+          </a:fontRef>
+        </p:style>
+        <p:txBody>
+          <a:bodyPr vert="vert" rtlCol="0" anchor="ctr"/>
+          <a:lstStyle/>
+          <a:p>
+            <a:pPr algn="ctr"/>
+            <a:r>
+              <a:rPr lang="en-US" sz="1400" b="1" dirty="0"/>
+              <a:t>4</a:t>
             </a:r>
           </a:p>
         </p:txBody>

</xml_diff>

<commit_message>
Alembic init + Claude wiring env.py to connect to my postgresql server specifically
</commit_message>
<xml_diff>
--- a/Project and Tool Layout.pptx
+++ b/Project and Tool Layout.pptx
@@ -3328,10 +3328,10 @@
       </p:grpSpPr>
       <p:sp>
         <p:nvSpPr>
-          <p:cNvPr id="15" name="Rectangle 14">
-            <a:extLst>
-              <a:ext uri="{FF2B5EF4-FFF2-40B4-BE49-F238E27FC236}">
-                <a16:creationId xmlns:a16="http://schemas.microsoft.com/office/drawing/2014/main" id="{9BCFF54A-ABDC-829F-D38E-19DC6F0A6EAE}"/>
+          <p:cNvPr id="7" name="Rectangle 6">
+            <a:extLst>
+              <a:ext uri="{FF2B5EF4-FFF2-40B4-BE49-F238E27FC236}">
+                <a16:creationId xmlns:a16="http://schemas.microsoft.com/office/drawing/2014/main" id="{1CE05274-4548-E41B-58C8-75D317FE550B}"/>
               </a:ext>
             </a:extLst>
           </p:cNvPr>
@@ -3340,8 +3340,127 @@
         </p:nvSpPr>
         <p:spPr>
           <a:xfrm>
-            <a:off x="6647580" y="1475052"/>
-            <a:ext cx="1314542" cy="4371762"/>
+            <a:off x="8367658" y="4125997"/>
+            <a:ext cx="993676" cy="1187945"/>
+          </a:xfrm>
+          <a:prstGeom prst="rect">
+            <a:avLst/>
+          </a:prstGeom>
+          <a:solidFill>
+            <a:schemeClr val="bg1">
+              <a:lumMod val="95000"/>
+            </a:schemeClr>
+          </a:solidFill>
+          <a:ln>
+            <a:prstDash val="dash"/>
+          </a:ln>
+        </p:spPr>
+        <p:style>
+          <a:lnRef idx="2">
+            <a:schemeClr val="accent1">
+              <a:shade val="15000"/>
+            </a:schemeClr>
+          </a:lnRef>
+          <a:fillRef idx="1">
+            <a:schemeClr val="accent1"/>
+          </a:fillRef>
+          <a:effectRef idx="0">
+            <a:schemeClr val="accent1"/>
+          </a:effectRef>
+          <a:fontRef idx="minor">
+            <a:schemeClr val="lt1"/>
+          </a:fontRef>
+        </p:style>
+        <p:txBody>
+          <a:bodyPr rtlCol="0" anchor="t"/>
+          <a:lstStyle/>
+          <a:p>
+            <a:pPr algn="ctr"/>
+            <a:r>
+              <a:rPr lang="en-US" sz="1200" dirty="0">
+                <a:solidFill>
+                  <a:schemeClr val="tx1"/>
+                </a:solidFill>
+              </a:rPr>
+              <a:t>On disk</a:t>
+            </a:r>
+          </a:p>
+        </p:txBody>
+      </p:sp>
+      <p:sp>
+        <p:nvSpPr>
+          <p:cNvPr id="73" name="Rectangle 72">
+            <a:extLst>
+              <a:ext uri="{FF2B5EF4-FFF2-40B4-BE49-F238E27FC236}">
+                <a16:creationId xmlns:a16="http://schemas.microsoft.com/office/drawing/2014/main" id="{1C37FB3A-8823-595A-E49C-1F3D559F712D}"/>
+              </a:ext>
+            </a:extLst>
+          </p:cNvPr>
+          <p:cNvSpPr/>
+          <p:nvPr/>
+        </p:nvSpPr>
+        <p:spPr>
+          <a:xfrm>
+            <a:off x="2338176" y="818595"/>
+            <a:ext cx="3492379" cy="1656606"/>
+          </a:xfrm>
+          <a:prstGeom prst="rect">
+            <a:avLst/>
+          </a:prstGeom>
+          <a:solidFill>
+            <a:schemeClr val="bg1">
+              <a:lumMod val="95000"/>
+            </a:schemeClr>
+          </a:solidFill>
+          <a:ln>
+            <a:prstDash val="dash"/>
+          </a:ln>
+        </p:spPr>
+        <p:style>
+          <a:lnRef idx="2">
+            <a:schemeClr val="accent1">
+              <a:shade val="15000"/>
+            </a:schemeClr>
+          </a:lnRef>
+          <a:fillRef idx="1">
+            <a:schemeClr val="accent1"/>
+          </a:fillRef>
+          <a:effectRef idx="0">
+            <a:schemeClr val="accent1"/>
+          </a:effectRef>
+          <a:fontRef idx="minor">
+            <a:schemeClr val="lt1"/>
+          </a:fontRef>
+        </p:style>
+        <p:txBody>
+          <a:bodyPr rtlCol="0" anchor="ctr"/>
+          <a:lstStyle/>
+          <a:p>
+            <a:pPr algn="ctr"/>
+            <a:endParaRPr lang="en-US" sz="1200" dirty="0">
+              <a:solidFill>
+                <a:schemeClr val="tx1"/>
+              </a:solidFill>
+            </a:endParaRPr>
+          </a:p>
+        </p:txBody>
+      </p:sp>
+      <p:sp>
+        <p:nvSpPr>
+          <p:cNvPr id="15" name="Rectangle 14">
+            <a:extLst>
+              <a:ext uri="{FF2B5EF4-FFF2-40B4-BE49-F238E27FC236}">
+                <a16:creationId xmlns:a16="http://schemas.microsoft.com/office/drawing/2014/main" id="{9BCFF54A-ABDC-829F-D38E-19DC6F0A6EAE}"/>
+              </a:ext>
+            </a:extLst>
+          </p:cNvPr>
+          <p:cNvSpPr/>
+          <p:nvPr/>
+        </p:nvSpPr>
+        <p:spPr>
+          <a:xfrm>
+            <a:off x="6647580" y="2736526"/>
+            <a:ext cx="1314542" cy="3110287"/>
           </a:xfrm>
           <a:prstGeom prst="rect">
             <a:avLst/>
@@ -3402,7 +3521,7 @@
         </p:nvSpPr>
         <p:spPr>
           <a:xfrm>
-            <a:off x="6647580" y="300845"/>
+            <a:off x="6647580" y="1526062"/>
             <a:ext cx="1314542" cy="922951"/>
           </a:xfrm>
           <a:prstGeom prst="rect">
@@ -3464,8 +3583,8 @@
         </p:nvSpPr>
         <p:spPr>
           <a:xfrm>
-            <a:off x="6706773" y="2054076"/>
-            <a:ext cx="1196156" cy="3392277"/>
+            <a:off x="6706773" y="3290505"/>
+            <a:ext cx="1196156" cy="2155848"/>
           </a:xfrm>
           <a:prstGeom prst="rect">
             <a:avLst/>
@@ -3928,7 +4047,7 @@
         </p:nvSpPr>
         <p:spPr>
           <a:xfrm>
-            <a:off x="2708398" y="1475053"/>
+            <a:off x="2726187" y="1051755"/>
             <a:ext cx="1256228" cy="1301519"/>
           </a:xfrm>
           <a:prstGeom prst="rect">
@@ -4014,7 +4133,7 @@
         </p:nvSpPr>
         <p:spPr>
           <a:xfrm>
-            <a:off x="2735094" y="1495077"/>
+            <a:off x="2752883" y="1071779"/>
             <a:ext cx="468643" cy="106792"/>
           </a:xfrm>
           <a:prstGeom prst="rect">
@@ -4067,8 +4186,8 @@
         </p:nvSpPr>
         <p:spPr>
           <a:xfrm>
-            <a:off x="2708397" y="3029953"/>
-            <a:ext cx="1256225" cy="1205979"/>
+            <a:off x="4355862" y="1051754"/>
+            <a:ext cx="1256225" cy="1301519"/>
           </a:xfrm>
           <a:prstGeom prst="rect">
             <a:avLst/>
@@ -4126,7 +4245,11 @@
           </a:p>
           <a:p>
             <a:pPr algn="ctr"/>
-            <a:endParaRPr lang="en-US" sz="1200" dirty="0"/>
+            <a:endParaRPr lang="en-US" sz="1100" dirty="0"/>
+          </a:p>
+          <a:p>
+            <a:pPr algn="ctr"/>
+            <a:endParaRPr lang="en-US" sz="1100" dirty="0"/>
           </a:p>
           <a:p>
             <a:pPr algn="ctr"/>
@@ -4166,7 +4289,7 @@
         </p:nvSpPr>
         <p:spPr>
           <a:xfrm>
-            <a:off x="2735094" y="3058805"/>
+            <a:off x="4382559" y="1080606"/>
             <a:ext cx="468643" cy="106884"/>
           </a:xfrm>
           <a:prstGeom prst="rect">
@@ -4216,15 +4339,15 @@
           </p:cNvPr>
           <p:cNvCxnSpPr>
             <a:cxnSpLocks/>
-            <a:stCxn id="22" idx="2"/>
-            <a:endCxn id="24" idx="0"/>
+            <a:stCxn id="22" idx="3"/>
+            <a:endCxn id="24" idx="1"/>
           </p:cNvCxnSpPr>
           <p:nvPr/>
         </p:nvCxnSpPr>
         <p:spPr>
-          <a:xfrm flipH="1">
-            <a:off x="3336510" y="2776572"/>
-            <a:ext cx="2" cy="253381"/>
+          <a:xfrm flipV="1">
+            <a:off x="3982415" y="1702514"/>
+            <a:ext cx="373447" cy="1"/>
           </a:xfrm>
           <a:prstGeom prst="line">
             <a:avLst/>
@@ -4265,8 +4388,8 @@
         </p:nvSpPr>
         <p:spPr>
           <a:xfrm>
-            <a:off x="4390043" y="1475052"/>
-            <a:ext cx="1256227" cy="687469"/>
+            <a:off x="2708399" y="2973922"/>
+            <a:ext cx="1256227" cy="862212"/>
           </a:xfrm>
           <a:prstGeom prst="rect">
             <a:avLst/>
@@ -4316,21 +4439,14 @@
             <a:pPr algn="ctr"/>
             <a:r>
               <a:rPr lang="en-US" sz="700" i="1" dirty="0"/>
-              <a:t>Creates SQL Scripts, </a:t>
+              <a:t>Uses DB Models to create .py scripts to interact with the DB, also maintains history of table</a:t>
             </a:r>
           </a:p>
           <a:p>
             <a:pPr algn="ctr"/>
             <a:r>
               <a:rPr lang="en-US" sz="700" i="1" dirty="0"/>
-              <a:t>also maintains field </a:t>
-            </a:r>
-          </a:p>
-          <a:p>
-            <a:pPr algn="ctr"/>
-            <a:r>
-              <a:rPr lang="en-US" sz="700" i="1" dirty="0"/>
-              <a:t>history in a file</a:t>
+              <a:t>shape for migrations</a:t>
             </a:r>
           </a:p>
         </p:txBody>
@@ -4349,7 +4465,7 @@
         </p:nvSpPr>
         <p:spPr>
           <a:xfrm>
-            <a:off x="4416739" y="1495076"/>
+            <a:off x="2735095" y="2993946"/>
             <a:ext cx="548737" cy="106790"/>
           </a:xfrm>
           <a:prstGeom prst="rect">
@@ -4388,25 +4504,131 @@
           </a:p>
         </p:txBody>
       </p:sp>
+      <p:sp>
+        <p:nvSpPr>
+          <p:cNvPr id="39" name="Rectangle 38">
+            <a:extLst>
+              <a:ext uri="{FF2B5EF4-FFF2-40B4-BE49-F238E27FC236}">
+                <a16:creationId xmlns:a16="http://schemas.microsoft.com/office/drawing/2014/main" id="{CB8C5D96-3572-ED9D-3C46-499AF5791C7B}"/>
+              </a:ext>
+            </a:extLst>
+          </p:cNvPr>
+          <p:cNvSpPr/>
+          <p:nvPr/>
+        </p:nvSpPr>
+        <p:spPr>
+          <a:xfrm>
+            <a:off x="4337114" y="2973922"/>
+            <a:ext cx="1257184" cy="862209"/>
+          </a:xfrm>
+          <a:prstGeom prst="rect">
+            <a:avLst/>
+          </a:prstGeom>
+          <a:solidFill>
+            <a:srgbClr val="7030A0"/>
+          </a:solidFill>
+        </p:spPr>
+        <p:style>
+          <a:lnRef idx="2">
+            <a:schemeClr val="accent1">
+              <a:shade val="15000"/>
+            </a:schemeClr>
+          </a:lnRef>
+          <a:fillRef idx="1">
+            <a:schemeClr val="accent1"/>
+          </a:fillRef>
+          <a:effectRef idx="0">
+            <a:schemeClr val="accent1"/>
+          </a:effectRef>
+          <a:fontRef idx="minor">
+            <a:schemeClr val="lt1"/>
+          </a:fontRef>
+        </p:style>
+        <p:txBody>
+          <a:bodyPr rtlCol="0" anchor="t"/>
+          <a:lstStyle/>
+          <a:p>
+            <a:pPr algn="ctr"/>
+            <a:r>
+              <a:rPr lang="en-US" sz="1200" dirty="0">
+                <a:solidFill>
+                  <a:schemeClr val="bg1"/>
+                </a:solidFill>
+              </a:rPr>
+              <a:t>Python Scripts</a:t>
+            </a:r>
+          </a:p>
+          <a:p>
+            <a:pPr algn="ctr"/>
+            <a:r>
+              <a:rPr lang="en-US" sz="1200" dirty="0">
+                <a:solidFill>
+                  <a:schemeClr val="bg1"/>
+                </a:solidFill>
+              </a:rPr>
+              <a:t>📚 </a:t>
+            </a:r>
+            <a:r>
+              <a:rPr lang="en-US" sz="1200" u="sng" dirty="0">
+                <a:solidFill>
+                  <a:schemeClr val="bg1"/>
+                </a:solidFill>
+              </a:rPr>
+              <a:t>SQLAlchemy</a:t>
+            </a:r>
+          </a:p>
+          <a:p>
+            <a:pPr algn="ctr"/>
+            <a:r>
+              <a:rPr lang="en-US" sz="1100" i="1" dirty="0">
+                <a:solidFill>
+                  <a:schemeClr val="bg1"/>
+                </a:solidFill>
+              </a:rPr>
+              <a:t>[Core features]</a:t>
+            </a:r>
+          </a:p>
+          <a:p>
+            <a:pPr algn="ctr"/>
+            <a:endParaRPr lang="en-US" sz="900" dirty="0">
+              <a:solidFill>
+                <a:schemeClr val="bg1"/>
+              </a:solidFill>
+            </a:endParaRPr>
+          </a:p>
+          <a:p>
+            <a:pPr algn="ctr"/>
+            <a:r>
+              <a:rPr lang="en-US" sz="900" dirty="0">
+                <a:solidFill>
+                  <a:schemeClr val="bg1"/>
+                </a:solidFill>
+              </a:rPr>
+              <a:t>= create empty tables</a:t>
+            </a:r>
+          </a:p>
+        </p:txBody>
+      </p:sp>
       <p:cxnSp>
         <p:nvCxnSpPr>
-          <p:cNvPr id="32" name="Straight Arrow Connector 31">
-            <a:extLst>
-              <a:ext uri="{FF2B5EF4-FFF2-40B4-BE49-F238E27FC236}">
-                <a16:creationId xmlns:a16="http://schemas.microsoft.com/office/drawing/2014/main" id="{25D63EDA-B8E8-A96D-4F52-2B2F83DD340F}"/>
+          <p:cNvPr id="40" name="Straight Arrow Connector 39">
+            <a:extLst>
+              <a:ext uri="{FF2B5EF4-FFF2-40B4-BE49-F238E27FC236}">
+                <a16:creationId xmlns:a16="http://schemas.microsoft.com/office/drawing/2014/main" id="{1AD9706D-EA7F-72ED-ECE2-A572DE446AF6}"/>
               </a:ext>
             </a:extLst>
           </p:cNvPr>
           <p:cNvCxnSpPr>
             <a:cxnSpLocks/>
-            <a:endCxn id="30" idx="1"/>
+            <a:stCxn id="30" idx="3"/>
+            <a:endCxn id="39" idx="1"/>
           </p:cNvCxnSpPr>
           <p:nvPr/>
         </p:nvCxnSpPr>
         <p:spPr>
-          <a:xfrm>
-            <a:off x="3964622" y="1818787"/>
-            <a:ext cx="425421" cy="0"/>
+          <a:xfrm flipV="1">
+            <a:off x="3964626" y="3405027"/>
+            <a:ext cx="372488" cy="1"/>
           </a:xfrm>
           <a:prstGeom prst="straightConnector1">
             <a:avLst/>
@@ -4433,100 +4655,24 @@
           </a:fontRef>
         </p:style>
       </p:cxnSp>
-      <p:sp>
-        <p:nvSpPr>
-          <p:cNvPr id="39" name="Rectangle 38">
-            <a:extLst>
-              <a:ext uri="{FF2B5EF4-FFF2-40B4-BE49-F238E27FC236}">
-                <a16:creationId xmlns:a16="http://schemas.microsoft.com/office/drawing/2014/main" id="{CB8C5D96-3572-ED9D-3C46-499AF5791C7B}"/>
-              </a:ext>
-            </a:extLst>
-          </p:cNvPr>
-          <p:cNvSpPr/>
-          <p:nvPr/>
-        </p:nvSpPr>
-        <p:spPr>
-          <a:xfrm>
-            <a:off x="4390042" y="2443683"/>
-            <a:ext cx="1256227" cy="545600"/>
-          </a:xfrm>
-          <a:prstGeom prst="rect">
-            <a:avLst/>
-          </a:prstGeom>
-          <a:solidFill>
-            <a:schemeClr val="bg1">
-              <a:lumMod val="85000"/>
-            </a:schemeClr>
-          </a:solidFill>
-        </p:spPr>
-        <p:style>
-          <a:lnRef idx="2">
-            <a:schemeClr val="accent1">
-              <a:shade val="15000"/>
-            </a:schemeClr>
-          </a:lnRef>
-          <a:fillRef idx="1">
-            <a:schemeClr val="accent1"/>
-          </a:fillRef>
-          <a:effectRef idx="0">
-            <a:schemeClr val="accent1"/>
-          </a:effectRef>
-          <a:fontRef idx="minor">
-            <a:schemeClr val="lt1"/>
-          </a:fontRef>
-        </p:style>
-        <p:txBody>
-          <a:bodyPr rtlCol="0" anchor="ctr"/>
-          <a:lstStyle/>
-          <a:p>
-            <a:pPr algn="ctr"/>
-            <a:r>
-              <a:rPr lang="en-US" sz="1200" dirty="0">
-                <a:solidFill>
-                  <a:schemeClr val="tx1"/>
-                </a:solidFill>
-              </a:rPr>
-              <a:t>SQL Scripts</a:t>
-            </a:r>
-          </a:p>
-          <a:p>
-            <a:pPr algn="ctr"/>
-            <a:r>
-              <a:rPr lang="en-US" sz="800" dirty="0">
-                <a:solidFill>
-                  <a:schemeClr val="tx1"/>
-                </a:solidFill>
-              </a:rPr>
-              <a:t>= creates empty tables</a:t>
-            </a:r>
-            <a:endParaRPr lang="en-US" sz="1200" dirty="0">
-              <a:solidFill>
-                <a:schemeClr val="tx1"/>
-              </a:solidFill>
-            </a:endParaRPr>
-          </a:p>
-        </p:txBody>
-      </p:sp>
       <p:cxnSp>
         <p:nvCxnSpPr>
-          <p:cNvPr id="40" name="Straight Arrow Connector 39">
-            <a:extLst>
-              <a:ext uri="{FF2B5EF4-FFF2-40B4-BE49-F238E27FC236}">
-                <a16:creationId xmlns:a16="http://schemas.microsoft.com/office/drawing/2014/main" id="{1AD9706D-EA7F-72ED-ECE2-A572DE446AF6}"/>
+          <p:cNvPr id="48" name="Straight Arrow Connector 47">
+            <a:extLst>
+              <a:ext uri="{FF2B5EF4-FFF2-40B4-BE49-F238E27FC236}">
+                <a16:creationId xmlns:a16="http://schemas.microsoft.com/office/drawing/2014/main" id="{868C1553-8B20-D677-F8CD-C7BFBCDD1FFA}"/>
               </a:ext>
             </a:extLst>
           </p:cNvPr>
           <p:cNvCxnSpPr>
             <a:cxnSpLocks/>
-            <a:stCxn id="30" idx="2"/>
-            <a:endCxn id="39" idx="0"/>
           </p:cNvCxnSpPr>
           <p:nvPr/>
         </p:nvCxnSpPr>
         <p:spPr>
-          <a:xfrm flipH="1">
-            <a:off x="5018156" y="2162521"/>
-            <a:ext cx="1" cy="281162"/>
+          <a:xfrm>
+            <a:off x="1871468" y="5059235"/>
+            <a:ext cx="836929" cy="0"/>
           </a:xfrm>
           <a:prstGeom prst="straightConnector1">
             <a:avLst/>
@@ -4553,50 +4699,6 @@
           </a:fontRef>
         </p:style>
       </p:cxnSp>
-      <p:cxnSp>
-        <p:nvCxnSpPr>
-          <p:cNvPr id="48" name="Straight Arrow Connector 47">
-            <a:extLst>
-              <a:ext uri="{FF2B5EF4-FFF2-40B4-BE49-F238E27FC236}">
-                <a16:creationId xmlns:a16="http://schemas.microsoft.com/office/drawing/2014/main" id="{868C1553-8B20-D677-F8CD-C7BFBCDD1FFA}"/>
-              </a:ext>
-            </a:extLst>
-          </p:cNvPr>
-          <p:cNvCxnSpPr>
-            <a:cxnSpLocks/>
-          </p:cNvCxnSpPr>
-          <p:nvPr/>
-        </p:nvCxnSpPr>
-        <p:spPr>
-          <a:xfrm>
-            <a:off x="1871468" y="5059235"/>
-            <a:ext cx="836929" cy="0"/>
-          </a:xfrm>
-          <a:prstGeom prst="straightConnector1">
-            <a:avLst/>
-          </a:prstGeom>
-          <a:ln w="12700">
-            <a:solidFill>
-              <a:schemeClr val="tx1"/>
-            </a:solidFill>
-            <a:tailEnd type="arrow"/>
-          </a:ln>
-        </p:spPr>
-        <p:style>
-          <a:lnRef idx="1">
-            <a:schemeClr val="accent1"/>
-          </a:lnRef>
-          <a:fillRef idx="0">
-            <a:schemeClr val="accent1"/>
-          </a:fillRef>
-          <a:effectRef idx="0">
-            <a:schemeClr val="accent1"/>
-          </a:effectRef>
-          <a:fontRef idx="minor">
-            <a:schemeClr val="tx1"/>
-          </a:fontRef>
-        </p:style>
-      </p:cxnSp>
       <p:sp>
         <p:nvSpPr>
           <p:cNvPr id="56" name="Rectangle 55">
@@ -4666,7 +4768,7 @@
             <a:pPr algn="ctr"/>
             <a:r>
               <a:rPr lang="en-US" sz="1050" i="1" dirty="0"/>
-              <a:t>[Insertion features]</a:t>
+              <a:t>[Core features]</a:t>
             </a:r>
           </a:p>
           <a:p>
@@ -4850,7 +4952,7 @@
         </p:nvGrpSpPr>
         <p:grpSpPr>
           <a:xfrm>
-            <a:off x="6970528" y="2629312"/>
+            <a:off x="8530653" y="4411817"/>
             <a:ext cx="680794" cy="785917"/>
             <a:chOff x="8227377" y="3019807"/>
             <a:chExt cx="680794" cy="785917"/>
@@ -5027,8 +5129,8 @@
         </p:nvCxnSpPr>
         <p:spPr>
           <a:xfrm>
-            <a:off x="5646269" y="2716483"/>
-            <a:ext cx="1060504" cy="0"/>
+            <a:off x="5594298" y="3405027"/>
+            <a:ext cx="1112475" cy="0"/>
           </a:xfrm>
           <a:prstGeom prst="straightConnector1">
             <a:avLst/>
@@ -5114,7 +5216,7 @@
         </p:nvSpPr>
         <p:spPr>
           <a:xfrm rot="16200000">
-            <a:off x="2451709" y="2935924"/>
+            <a:off x="4099174" y="957725"/>
             <a:ext cx="186884" cy="240280"/>
           </a:xfrm>
           <a:prstGeom prst="flowChartOffpageConnector">
@@ -5168,7 +5270,7 @@
         </p:nvSpPr>
         <p:spPr>
           <a:xfrm rot="16200000">
-            <a:off x="2451709" y="1361461"/>
+            <a:off x="2469498" y="938163"/>
             <a:ext cx="186884" cy="240280"/>
           </a:xfrm>
           <a:prstGeom prst="flowChartOffpageConnector">
@@ -5222,7 +5324,7 @@
         </p:nvSpPr>
         <p:spPr>
           <a:xfrm rot="16200000">
-            <a:off x="4156555" y="1361461"/>
+            <a:off x="2474911" y="2860331"/>
             <a:ext cx="186884" cy="240280"/>
           </a:xfrm>
           <a:prstGeom prst="flowChartOffpageConnector">
@@ -5276,7 +5378,7 @@
         </p:nvSpPr>
         <p:spPr>
           <a:xfrm>
-            <a:off x="6074182" y="2272527"/>
+            <a:off x="6031126" y="2957497"/>
             <a:ext cx="186884" cy="240280"/>
           </a:xfrm>
           <a:prstGeom prst="flowChartOffpageConnector">
@@ -5438,7 +5540,7 @@
         </p:nvSpPr>
         <p:spPr>
           <a:xfrm>
-            <a:off x="5927185" y="2529424"/>
+            <a:off x="5884129" y="3214394"/>
             <a:ext cx="452047" cy="169277"/>
           </a:xfrm>
           <a:prstGeom prst="rect">
@@ -5542,7 +5644,7 @@
         </p:nvSpPr>
         <p:spPr>
           <a:xfrm>
-            <a:off x="4581610" y="3022272"/>
+            <a:off x="4529165" y="3886609"/>
             <a:ext cx="873082" cy="248173"/>
           </a:xfrm>
           <a:prstGeom prst="rect">
@@ -5602,7 +5704,7 @@
         </p:nvSpPr>
         <p:spPr>
           <a:xfrm>
-            <a:off x="4581609" y="5900631"/>
+            <a:off x="4529165" y="5900631"/>
             <a:ext cx="873083" cy="249337"/>
           </a:xfrm>
           <a:prstGeom prst="rect">
@@ -5718,7 +5820,7 @@
         </p:nvSpPr>
         <p:spPr>
           <a:xfrm>
-            <a:off x="5873611" y="2744030"/>
+            <a:off x="5830555" y="3429000"/>
             <a:ext cx="548227" cy="138499"/>
           </a:xfrm>
           <a:prstGeom prst="rect">
@@ -5790,7 +5892,7 @@
         </p:nvSpPr>
         <p:spPr>
           <a:xfrm>
-            <a:off x="6707651" y="681289"/>
+            <a:off x="6707651" y="1906506"/>
             <a:ext cx="1196156" cy="500584"/>
           </a:xfrm>
           <a:prstGeom prst="rect">
@@ -5865,8 +5967,8 @@
         </p:nvCxnSpPr>
         <p:spPr>
           <a:xfrm>
-            <a:off x="7304851" y="1223796"/>
-            <a:ext cx="0" cy="251256"/>
+            <a:off x="7304851" y="2449013"/>
+            <a:ext cx="0" cy="287513"/>
           </a:xfrm>
           <a:prstGeom prst="straightConnector1">
             <a:avLst/>
@@ -5908,7 +6010,7 @@
         </p:nvSpPr>
         <p:spPr>
           <a:xfrm>
-            <a:off x="6839157" y="3613093"/>
+            <a:off x="6839157" y="3842999"/>
             <a:ext cx="931388" cy="347071"/>
           </a:xfrm>
           <a:prstGeom prst="rect">
@@ -5967,7 +6069,7 @@
         </p:nvSpPr>
         <p:spPr>
           <a:xfrm rot="16200000">
-            <a:off x="6405930" y="180705"/>
+            <a:off x="6405930" y="1405922"/>
             <a:ext cx="186884" cy="240280"/>
           </a:xfrm>
           <a:prstGeom prst="flowChartOffpageConnector">
@@ -6021,7 +6123,7 @@
         </p:nvSpPr>
         <p:spPr>
           <a:xfrm rot="16200000">
-            <a:off x="6405930" y="1354912"/>
+            <a:off x="6405930" y="2666644"/>
             <a:ext cx="186884" cy="240280"/>
           </a:xfrm>
           <a:prstGeom prst="flowChartOffpageConnector">
@@ -6061,6 +6163,51 @@
           </a:p>
         </p:txBody>
       </p:sp>
+      <p:cxnSp>
+        <p:nvCxnSpPr>
+          <p:cNvPr id="9" name="Straight Arrow Connector 8">
+            <a:extLst>
+              <a:ext uri="{FF2B5EF4-FFF2-40B4-BE49-F238E27FC236}">
+                <a16:creationId xmlns:a16="http://schemas.microsoft.com/office/drawing/2014/main" id="{9458E378-64A6-E028-0C10-0269BED70907}"/>
+              </a:ext>
+            </a:extLst>
+          </p:cNvPr>
+          <p:cNvCxnSpPr>
+            <a:cxnSpLocks/>
+          </p:cNvCxnSpPr>
+          <p:nvPr/>
+        </p:nvCxnSpPr>
+        <p:spPr>
+          <a:xfrm>
+            <a:off x="7902929" y="4750067"/>
+            <a:ext cx="627724" cy="0"/>
+          </a:xfrm>
+          <a:prstGeom prst="straightConnector1">
+            <a:avLst/>
+          </a:prstGeom>
+          <a:ln w="12700">
+            <a:solidFill>
+              <a:schemeClr val="tx1"/>
+            </a:solidFill>
+            <a:headEnd type="arrow"/>
+            <a:tailEnd type="arrow"/>
+          </a:ln>
+        </p:spPr>
+        <p:style>
+          <a:lnRef idx="1">
+            <a:schemeClr val="accent1"/>
+          </a:lnRef>
+          <a:fillRef idx="0">
+            <a:schemeClr val="accent1"/>
+          </a:fillRef>
+          <a:effectRef idx="0">
+            <a:schemeClr val="accent1"/>
+          </a:effectRef>
+          <a:fontRef idx="minor">
+            <a:schemeClr val="tx1"/>
+          </a:fontRef>
+        </p:style>
+      </p:cxnSp>
     </p:spTree>
     <p:extLst>
       <p:ext uri="{BB962C8B-B14F-4D97-AF65-F5344CB8AC3E}">

</xml_diff>

<commit_message>
Adding data loader and creating a test db which should match the real xbrl db, used to verify data goes in and comes back out as expected
</commit_message>
<xml_diff>
--- a/Project and Tool Layout.pptx
+++ b/Project and Tool Layout.pptx
@@ -259,7 +259,7 @@
           <a:p>
             <a:fld id="{E779FE8C-703A-4904-A4E0-13778480428C}" type="datetimeFigureOut">
               <a:rPr lang="en-US" smtClean="0"/>
-              <a:t>8/30/2026</a:t>
+              <a:t>8/31/2026</a:t>
             </a:fld>
             <a:endParaRPr lang="en-US"/>
           </a:p>
@@ -457,7 +457,7 @@
           <a:p>
             <a:fld id="{E779FE8C-703A-4904-A4E0-13778480428C}" type="datetimeFigureOut">
               <a:rPr lang="en-US" smtClean="0"/>
-              <a:t>8/30/2026</a:t>
+              <a:t>8/31/2026</a:t>
             </a:fld>
             <a:endParaRPr lang="en-US"/>
           </a:p>
@@ -665,7 +665,7 @@
           <a:p>
             <a:fld id="{E779FE8C-703A-4904-A4E0-13778480428C}" type="datetimeFigureOut">
               <a:rPr lang="en-US" smtClean="0"/>
-              <a:t>8/30/2026</a:t>
+              <a:t>8/31/2026</a:t>
             </a:fld>
             <a:endParaRPr lang="en-US"/>
           </a:p>
@@ -863,7 +863,7 @@
           <a:p>
             <a:fld id="{E779FE8C-703A-4904-A4E0-13778480428C}" type="datetimeFigureOut">
               <a:rPr lang="en-US" smtClean="0"/>
-              <a:t>8/30/2026</a:t>
+              <a:t>8/31/2026</a:t>
             </a:fld>
             <a:endParaRPr lang="en-US"/>
           </a:p>
@@ -1138,7 +1138,7 @@
           <a:p>
             <a:fld id="{E779FE8C-703A-4904-A4E0-13778480428C}" type="datetimeFigureOut">
               <a:rPr lang="en-US" smtClean="0"/>
-              <a:t>8/30/2026</a:t>
+              <a:t>8/31/2026</a:t>
             </a:fld>
             <a:endParaRPr lang="en-US"/>
           </a:p>
@@ -1403,7 +1403,7 @@
           <a:p>
             <a:fld id="{E779FE8C-703A-4904-A4E0-13778480428C}" type="datetimeFigureOut">
               <a:rPr lang="en-US" smtClean="0"/>
-              <a:t>8/30/2026</a:t>
+              <a:t>8/31/2026</a:t>
             </a:fld>
             <a:endParaRPr lang="en-US"/>
           </a:p>
@@ -1815,7 +1815,7 @@
           <a:p>
             <a:fld id="{E779FE8C-703A-4904-A4E0-13778480428C}" type="datetimeFigureOut">
               <a:rPr lang="en-US" smtClean="0"/>
-              <a:t>8/30/2026</a:t>
+              <a:t>8/31/2026</a:t>
             </a:fld>
             <a:endParaRPr lang="en-US"/>
           </a:p>
@@ -1956,7 +1956,7 @@
           <a:p>
             <a:fld id="{E779FE8C-703A-4904-A4E0-13778480428C}" type="datetimeFigureOut">
               <a:rPr lang="en-US" smtClean="0"/>
-              <a:t>8/30/2026</a:t>
+              <a:t>8/31/2026</a:t>
             </a:fld>
             <a:endParaRPr lang="en-US"/>
           </a:p>
@@ -2069,7 +2069,7 @@
           <a:p>
             <a:fld id="{E779FE8C-703A-4904-A4E0-13778480428C}" type="datetimeFigureOut">
               <a:rPr lang="en-US" smtClean="0"/>
-              <a:t>8/30/2026</a:t>
+              <a:t>8/31/2026</a:t>
             </a:fld>
             <a:endParaRPr lang="en-US"/>
           </a:p>
@@ -2380,7 +2380,7 @@
           <a:p>
             <a:fld id="{E779FE8C-703A-4904-A4E0-13778480428C}" type="datetimeFigureOut">
               <a:rPr lang="en-US" smtClean="0"/>
-              <a:t>8/30/2026</a:t>
+              <a:t>8/31/2026</a:t>
             </a:fld>
             <a:endParaRPr lang="en-US"/>
           </a:p>
@@ -2668,7 +2668,7 @@
           <a:p>
             <a:fld id="{E779FE8C-703A-4904-A4E0-13778480428C}" type="datetimeFigureOut">
               <a:rPr lang="en-US" smtClean="0"/>
-              <a:t>8/30/2026</a:t>
+              <a:t>8/31/2026</a:t>
             </a:fld>
             <a:endParaRPr lang="en-US"/>
           </a:p>
@@ -2909,7 +2909,7 @@
           <a:p>
             <a:fld id="{E779FE8C-703A-4904-A4E0-13778480428C}" type="datetimeFigureOut">
               <a:rPr lang="en-US" smtClean="0"/>
-              <a:t>8/30/2026</a:t>
+              <a:t>8/31/2026</a:t>
             </a:fld>
             <a:endParaRPr lang="en-US"/>
           </a:p>
@@ -3459,8 +3459,8 @@
         </p:nvSpPr>
         <p:spPr>
           <a:xfrm>
-            <a:off x="6647580" y="2736526"/>
-            <a:ext cx="1314542" cy="3110287"/>
+            <a:off x="6647580" y="2736527"/>
+            <a:ext cx="1314542" cy="2595411"/>
           </a:xfrm>
           <a:prstGeom prst="rect">
             <a:avLst/>
@@ -3584,7 +3584,7 @@
         <p:spPr>
           <a:xfrm>
             <a:off x="6706773" y="3290505"/>
-            <a:ext cx="1196156" cy="2155848"/>
+            <a:ext cx="1196156" cy="1978181"/>
           </a:xfrm>
           <a:prstGeom prst="rect">
             <a:avLst/>
@@ -5579,7 +5579,7 @@
         </p:nvSpPr>
         <p:spPr>
           <a:xfrm>
-            <a:off x="6706773" y="5909454"/>
+            <a:off x="6706773" y="1120013"/>
             <a:ext cx="1196156" cy="321580"/>
           </a:xfrm>
           <a:prstGeom prst="rect">
@@ -5972,7 +5972,7 @@
         <p:spPr>
           <a:xfrm>
             <a:off x="7304851" y="2449013"/>
-            <a:ext cx="0" cy="287513"/>
+            <a:ext cx="0" cy="287514"/>
           </a:xfrm>
           <a:prstGeom prst="straightConnector1">
             <a:avLst/>
@@ -6184,6 +6184,466 @@
         <p:spPr>
           <a:xfrm>
             <a:off x="7902929" y="4750067"/>
+            <a:ext cx="627724" cy="0"/>
+          </a:xfrm>
+          <a:prstGeom prst="straightConnector1">
+            <a:avLst/>
+          </a:prstGeom>
+          <a:ln w="12700">
+            <a:solidFill>
+              <a:schemeClr val="tx1"/>
+            </a:solidFill>
+            <a:headEnd type="arrow"/>
+            <a:tailEnd type="arrow"/>
+          </a:ln>
+        </p:spPr>
+        <p:style>
+          <a:lnRef idx="1">
+            <a:schemeClr val="accent1"/>
+          </a:lnRef>
+          <a:fillRef idx="0">
+            <a:schemeClr val="accent1"/>
+          </a:fillRef>
+          <a:effectRef idx="0">
+            <a:schemeClr val="accent1"/>
+          </a:effectRef>
+          <a:fontRef idx="minor">
+            <a:schemeClr val="tx1"/>
+          </a:fontRef>
+        </p:style>
+      </p:cxnSp>
+      <p:sp>
+        <p:nvSpPr>
+          <p:cNvPr id="14" name="Rectangle 13">
+            <a:extLst>
+              <a:ext uri="{FF2B5EF4-FFF2-40B4-BE49-F238E27FC236}">
+                <a16:creationId xmlns:a16="http://schemas.microsoft.com/office/drawing/2014/main" id="{7B3D0089-C192-CA16-D91B-29EDF91F0A0B}"/>
+              </a:ext>
+            </a:extLst>
+          </p:cNvPr>
+          <p:cNvSpPr/>
+          <p:nvPr/>
+        </p:nvSpPr>
+        <p:spPr>
+          <a:xfrm>
+            <a:off x="6647580" y="5387637"/>
+            <a:ext cx="1314542" cy="740680"/>
+          </a:xfrm>
+          <a:prstGeom prst="rect">
+            <a:avLst/>
+          </a:prstGeom>
+          <a:solidFill>
+            <a:schemeClr val="accent1">
+              <a:lumMod val="40000"/>
+              <a:lumOff val="60000"/>
+            </a:schemeClr>
+          </a:solidFill>
+        </p:spPr>
+        <p:style>
+          <a:lnRef idx="2">
+            <a:schemeClr val="accent1">
+              <a:shade val="15000"/>
+            </a:schemeClr>
+          </a:lnRef>
+          <a:fillRef idx="1">
+            <a:schemeClr val="accent1"/>
+          </a:fillRef>
+          <a:effectRef idx="0">
+            <a:schemeClr val="accent1"/>
+          </a:effectRef>
+          <a:fontRef idx="minor">
+            <a:schemeClr val="lt1"/>
+          </a:fontRef>
+        </p:style>
+        <p:txBody>
+          <a:bodyPr lIns="0" tIns="45720" rIns="0" bIns="0" rtlCol="0" anchor="t"/>
+          <a:lstStyle/>
+          <a:p>
+            <a:pPr algn="ctr"/>
+            <a:r>
+              <a:rPr lang="en-US" sz="900" b="1" dirty="0"/>
+              <a:t>🐳 Docker Container</a:t>
+            </a:r>
+          </a:p>
+          <a:p>
+            <a:pPr algn="ctr"/>
+            <a:r>
+              <a:rPr lang="en-US" sz="900" i="1" dirty="0"/>
+              <a:t>“pgvector/pgvector:pg17”</a:t>
+            </a:r>
+          </a:p>
+        </p:txBody>
+      </p:sp>
+      <p:sp>
+        <p:nvSpPr>
+          <p:cNvPr id="16" name="Rectangle 15">
+            <a:extLst>
+              <a:ext uri="{FF2B5EF4-FFF2-40B4-BE49-F238E27FC236}">
+                <a16:creationId xmlns:a16="http://schemas.microsoft.com/office/drawing/2014/main" id="{587C3EA7-BCBD-F703-4C04-1F10B55FC777}"/>
+              </a:ext>
+            </a:extLst>
+          </p:cNvPr>
+          <p:cNvSpPr/>
+          <p:nvPr/>
+        </p:nvSpPr>
+        <p:spPr>
+          <a:xfrm>
+            <a:off x="6706773" y="5724040"/>
+            <a:ext cx="1196156" cy="356069"/>
+          </a:xfrm>
+          <a:prstGeom prst="rect">
+            <a:avLst/>
+          </a:prstGeom>
+          <a:solidFill>
+            <a:schemeClr val="accent2">
+              <a:lumMod val="60000"/>
+              <a:lumOff val="40000"/>
+            </a:schemeClr>
+          </a:solidFill>
+        </p:spPr>
+        <p:style>
+          <a:lnRef idx="2">
+            <a:schemeClr val="accent1">
+              <a:shade val="15000"/>
+            </a:schemeClr>
+          </a:lnRef>
+          <a:fillRef idx="1">
+            <a:schemeClr val="accent1"/>
+          </a:fillRef>
+          <a:effectRef idx="0">
+            <a:schemeClr val="accent1"/>
+          </a:effectRef>
+          <a:fontRef idx="minor">
+            <a:schemeClr val="lt1"/>
+          </a:fontRef>
+        </p:style>
+        <p:txBody>
+          <a:bodyPr lIns="0" tIns="0" rIns="0" bIns="0" rtlCol="0" anchor="t"/>
+          <a:lstStyle/>
+          <a:p>
+            <a:pPr algn="ctr"/>
+            <a:r>
+              <a:rPr lang="en-US" sz="1050" b="1" dirty="0"/>
+              <a:t>Test</a:t>
+            </a:r>
+            <a:r>
+              <a:rPr lang="en-US" sz="900" dirty="0"/>
+              <a:t> PostgreSQL Server</a:t>
+            </a:r>
+          </a:p>
+        </p:txBody>
+      </p:sp>
+      <p:sp>
+        <p:nvSpPr>
+          <p:cNvPr id="17" name="Rectangle 16">
+            <a:extLst>
+              <a:ext uri="{FF2B5EF4-FFF2-40B4-BE49-F238E27FC236}">
+                <a16:creationId xmlns:a16="http://schemas.microsoft.com/office/drawing/2014/main" id="{2B814015-7DE2-E6CF-83DF-F2CFE2A7AB61}"/>
+              </a:ext>
+            </a:extLst>
+          </p:cNvPr>
+          <p:cNvSpPr/>
+          <p:nvPr/>
+        </p:nvSpPr>
+        <p:spPr>
+          <a:xfrm>
+            <a:off x="6914467" y="5906573"/>
+            <a:ext cx="780768" cy="149563"/>
+          </a:xfrm>
+          <a:prstGeom prst="rect">
+            <a:avLst/>
+          </a:prstGeom>
+          <a:solidFill>
+            <a:schemeClr val="accent2">
+              <a:lumMod val="60000"/>
+              <a:lumOff val="40000"/>
+            </a:schemeClr>
+          </a:solidFill>
+        </p:spPr>
+        <p:style>
+          <a:lnRef idx="2">
+            <a:schemeClr val="accent1">
+              <a:shade val="15000"/>
+            </a:schemeClr>
+          </a:lnRef>
+          <a:fillRef idx="1">
+            <a:schemeClr val="accent1"/>
+          </a:fillRef>
+          <a:effectRef idx="0">
+            <a:schemeClr val="accent1"/>
+          </a:effectRef>
+          <a:fontRef idx="minor">
+            <a:schemeClr val="lt1"/>
+          </a:fontRef>
+        </p:style>
+        <p:txBody>
+          <a:bodyPr lIns="0" tIns="0" rIns="0" bIns="0" rtlCol="0" anchor="ctr"/>
+          <a:lstStyle/>
+          <a:p>
+            <a:pPr algn="ctr"/>
+            <a:r>
+              <a:rPr lang="en-US" sz="800" dirty="0"/>
+              <a:t>📚 </a:t>
+            </a:r>
+            <a:r>
+              <a:rPr lang="en-US" sz="800" b="1" u="sng" dirty="0"/>
+              <a:t>pg-vector</a:t>
+            </a:r>
+          </a:p>
+        </p:txBody>
+      </p:sp>
+      <p:sp>
+        <p:nvSpPr>
+          <p:cNvPr id="19" name="Rectangle 18">
+            <a:extLst>
+              <a:ext uri="{FF2B5EF4-FFF2-40B4-BE49-F238E27FC236}">
+                <a16:creationId xmlns:a16="http://schemas.microsoft.com/office/drawing/2014/main" id="{A1E4815B-12EB-5B81-7205-419D7DA693D5}"/>
+              </a:ext>
+            </a:extLst>
+          </p:cNvPr>
+          <p:cNvSpPr/>
+          <p:nvPr/>
+        </p:nvSpPr>
+        <p:spPr>
+          <a:xfrm>
+            <a:off x="8367658" y="5468951"/>
+            <a:ext cx="993676" cy="740680"/>
+          </a:xfrm>
+          <a:prstGeom prst="rect">
+            <a:avLst/>
+          </a:prstGeom>
+          <a:solidFill>
+            <a:schemeClr val="bg1">
+              <a:lumMod val="95000"/>
+            </a:schemeClr>
+          </a:solidFill>
+          <a:ln>
+            <a:prstDash val="dash"/>
+          </a:ln>
+        </p:spPr>
+        <p:style>
+          <a:lnRef idx="2">
+            <a:schemeClr val="accent1">
+              <a:shade val="15000"/>
+            </a:schemeClr>
+          </a:lnRef>
+          <a:fillRef idx="1">
+            <a:schemeClr val="accent1"/>
+          </a:fillRef>
+          <a:effectRef idx="0">
+            <a:schemeClr val="accent1"/>
+          </a:effectRef>
+          <a:fontRef idx="minor">
+            <a:schemeClr val="lt1"/>
+          </a:fontRef>
+        </p:style>
+        <p:txBody>
+          <a:bodyPr rtlCol="0" anchor="t"/>
+          <a:lstStyle/>
+          <a:p>
+            <a:pPr algn="ctr"/>
+            <a:r>
+              <a:rPr lang="en-US" sz="1200" dirty="0">
+                <a:solidFill>
+                  <a:schemeClr val="tx1"/>
+                </a:solidFill>
+              </a:rPr>
+              <a:t>On disk</a:t>
+            </a:r>
+          </a:p>
+        </p:txBody>
+      </p:sp>
+      <p:grpSp>
+        <p:nvGrpSpPr>
+          <p:cNvPr id="20" name="Group 19">
+            <a:extLst>
+              <a:ext uri="{FF2B5EF4-FFF2-40B4-BE49-F238E27FC236}">
+                <a16:creationId xmlns:a16="http://schemas.microsoft.com/office/drawing/2014/main" id="{CC8943CF-9BDA-943E-7ABF-BA2E147A52A4}"/>
+              </a:ext>
+            </a:extLst>
+          </p:cNvPr>
+          <p:cNvGrpSpPr/>
+          <p:nvPr/>
+        </p:nvGrpSpPr>
+        <p:grpSpPr>
+          <a:xfrm>
+            <a:off x="8530653" y="5721371"/>
+            <a:ext cx="680794" cy="433282"/>
+            <a:chOff x="8227377" y="3019807"/>
+            <a:chExt cx="680794" cy="785917"/>
+          </a:xfrm>
+        </p:grpSpPr>
+        <p:sp>
+          <p:nvSpPr>
+            <p:cNvPr id="21" name="Flowchart: Magnetic Disk 20">
+              <a:extLst>
+                <a:ext uri="{FF2B5EF4-FFF2-40B4-BE49-F238E27FC236}">
+                  <a16:creationId xmlns:a16="http://schemas.microsoft.com/office/drawing/2014/main" id="{D916B6ED-0FC3-F870-6017-EB076408A9BA}"/>
+                </a:ext>
+              </a:extLst>
+            </p:cNvPr>
+            <p:cNvSpPr/>
+            <p:nvPr/>
+          </p:nvSpPr>
+          <p:spPr>
+            <a:xfrm>
+              <a:off x="8227377" y="3458653"/>
+              <a:ext cx="680794" cy="347071"/>
+            </a:xfrm>
+            <a:prstGeom prst="flowChartMagneticDisk">
+              <a:avLst/>
+            </a:prstGeom>
+            <a:solidFill>
+              <a:schemeClr val="accent2">
+                <a:lumMod val="75000"/>
+              </a:schemeClr>
+            </a:solidFill>
+          </p:spPr>
+          <p:style>
+            <a:lnRef idx="2">
+              <a:schemeClr val="accent1">
+                <a:shade val="15000"/>
+              </a:schemeClr>
+            </a:lnRef>
+            <a:fillRef idx="1">
+              <a:schemeClr val="accent1"/>
+            </a:fillRef>
+            <a:effectRef idx="0">
+              <a:schemeClr val="accent1"/>
+            </a:effectRef>
+            <a:fontRef idx="minor">
+              <a:schemeClr val="lt1"/>
+            </a:fontRef>
+          </p:style>
+          <p:txBody>
+            <a:bodyPr rtlCol="0" anchor="ctr"/>
+            <a:lstStyle/>
+            <a:p>
+              <a:pPr algn="ctr"/>
+              <a:endParaRPr lang="en-US"/>
+            </a:p>
+          </p:txBody>
+        </p:sp>
+        <p:sp>
+          <p:nvSpPr>
+            <p:cNvPr id="25" name="Flowchart: Magnetic Disk 24">
+              <a:extLst>
+                <a:ext uri="{FF2B5EF4-FFF2-40B4-BE49-F238E27FC236}">
+                  <a16:creationId xmlns:a16="http://schemas.microsoft.com/office/drawing/2014/main" id="{CF8DF804-5F62-9364-1A0F-B5B8FB9D3AE2}"/>
+                </a:ext>
+              </a:extLst>
+            </p:cNvPr>
+            <p:cNvSpPr/>
+            <p:nvPr/>
+          </p:nvSpPr>
+          <p:spPr>
+            <a:xfrm>
+              <a:off x="8227377" y="3235058"/>
+              <a:ext cx="680794" cy="347071"/>
+            </a:xfrm>
+            <a:prstGeom prst="flowChartMagneticDisk">
+              <a:avLst/>
+            </a:prstGeom>
+            <a:solidFill>
+              <a:schemeClr val="accent2">
+                <a:lumMod val="75000"/>
+              </a:schemeClr>
+            </a:solidFill>
+          </p:spPr>
+          <p:style>
+            <a:lnRef idx="2">
+              <a:schemeClr val="accent1">
+                <a:shade val="15000"/>
+              </a:schemeClr>
+            </a:lnRef>
+            <a:fillRef idx="1">
+              <a:schemeClr val="accent1"/>
+            </a:fillRef>
+            <a:effectRef idx="0">
+              <a:schemeClr val="accent1"/>
+            </a:effectRef>
+            <a:fontRef idx="minor">
+              <a:schemeClr val="lt1"/>
+            </a:fontRef>
+          </p:style>
+          <p:txBody>
+            <a:bodyPr rtlCol="0" anchor="ctr"/>
+            <a:lstStyle/>
+            <a:p>
+              <a:pPr algn="ctr"/>
+              <a:endParaRPr lang="en-US"/>
+            </a:p>
+          </p:txBody>
+        </p:sp>
+        <p:sp>
+          <p:nvSpPr>
+            <p:cNvPr id="29" name="Flowchart: Magnetic Disk 28">
+              <a:extLst>
+                <a:ext uri="{FF2B5EF4-FFF2-40B4-BE49-F238E27FC236}">
+                  <a16:creationId xmlns:a16="http://schemas.microsoft.com/office/drawing/2014/main" id="{A8A091E6-56B1-41BE-00E9-F708DF430EB6}"/>
+                </a:ext>
+              </a:extLst>
+            </p:cNvPr>
+            <p:cNvSpPr/>
+            <p:nvPr/>
+          </p:nvSpPr>
+          <p:spPr>
+            <a:xfrm>
+              <a:off x="8227377" y="3019807"/>
+              <a:ext cx="680794" cy="347071"/>
+            </a:xfrm>
+            <a:prstGeom prst="flowChartMagneticDisk">
+              <a:avLst/>
+            </a:prstGeom>
+            <a:solidFill>
+              <a:schemeClr val="accent2">
+                <a:lumMod val="75000"/>
+              </a:schemeClr>
+            </a:solidFill>
+          </p:spPr>
+          <p:style>
+            <a:lnRef idx="2">
+              <a:schemeClr val="accent1">
+                <a:shade val="15000"/>
+              </a:schemeClr>
+            </a:lnRef>
+            <a:fillRef idx="1">
+              <a:schemeClr val="accent1"/>
+            </a:fillRef>
+            <a:effectRef idx="0">
+              <a:schemeClr val="accent1"/>
+            </a:effectRef>
+            <a:fontRef idx="minor">
+              <a:schemeClr val="lt1"/>
+            </a:fontRef>
+          </p:style>
+          <p:txBody>
+            <a:bodyPr rtlCol="0" anchor="ctr"/>
+            <a:lstStyle/>
+            <a:p>
+              <a:pPr algn="ctr"/>
+              <a:endParaRPr lang="en-US"/>
+            </a:p>
+          </p:txBody>
+        </p:sp>
+      </p:grpSp>
+      <p:cxnSp>
+        <p:nvCxnSpPr>
+          <p:cNvPr id="32" name="Straight Arrow Connector 31">
+            <a:extLst>
+              <a:ext uri="{FF2B5EF4-FFF2-40B4-BE49-F238E27FC236}">
+                <a16:creationId xmlns:a16="http://schemas.microsoft.com/office/drawing/2014/main" id="{24D0FA54-77BE-D97F-B793-0D61F01A3D24}"/>
+              </a:ext>
+            </a:extLst>
+          </p:cNvPr>
+          <p:cNvCxnSpPr>
+            <a:cxnSpLocks/>
+          </p:cNvCxnSpPr>
+          <p:nvPr/>
+        </p:nvCxnSpPr>
+        <p:spPr>
+          <a:xfrm>
+            <a:off x="7902929" y="5961104"/>
             <a:ext cx="627724" cy="0"/>
           </a:xfrm>
           <a:prstGeom prst="straightConnector1">

</xml_diff>